<commit_message>
Refine Week 1 classroom resources
Co-authored-by: Cursor <cursoragent@cursor.com>
</commit_message>
<xml_diff>
--- a/production/slides/02-ch2-moving-objects-have-energy-slides.pptx
+++ b/production/slides/02-ch2-moving-objects-have-energy-slides.pptx
@@ -3219,7 +3219,7 @@
                 </a:solidFill>
                 <a:latin typeface="Arial"/>
               </a:rPr>
-              <a:t>Chapter 2  ·  Grade 4  ·  Week 2</a:t>
+              <a:t>Chapter 2  ·  Grade 4  ·  Week 1</a:t>
             </a:r>
           </a:p>
         </p:txBody>
@@ -3719,7 +3719,7 @@
         <p:spPr>
           <a:xfrm>
             <a:off x="457200" y="146304"/>
-            <a:ext cx="11247120" cy="777240"/>
+            <a:ext cx="10058400" cy="777240"/>
           </a:xfrm>
           <a:prstGeom prst="rect">
             <a:avLst/>
@@ -3734,13 +3734,13 @@
           <a:p>
             <a:pPr algn="l"/>
             <a:r>
-              <a:rPr sz="3400" b="1">
+              <a:rPr sz="3400" b="1" i="0">
                 <a:solidFill>
                   <a:srgbClr val="FFFFFF"/>
                 </a:solidFill>
                 <a:latin typeface="Arial"/>
               </a:rPr>
-              <a:t>Energy of motion</a:t>
+              <a:t>Notes — Motion</a:t>
             </a:r>
           </a:p>
         </p:txBody>
@@ -3753,8 +3753,8 @@
         </p:nvSpPr>
         <p:spPr>
           <a:xfrm>
-            <a:off x="1097280" y="2377440"/>
-            <a:ext cx="9966960" cy="1737360"/>
+            <a:off x="9692640" y="256032"/>
+            <a:ext cx="2103120" cy="548640"/>
           </a:xfrm>
           <a:prstGeom prst="roundRect">
             <a:avLst/>
@@ -3786,27 +3786,70 @@
           <a:p>
             <a:pPr algn="ctr"/>
             <a:r>
-              <a:rPr sz="3000" b="1">
+              <a:rPr sz="1800" b="1">
                 <a:solidFill>
                   <a:srgbClr val="FFFFFF"/>
                 </a:solidFill>
                 <a:latin typeface="Arial"/>
               </a:rPr>
-              <a:t>A moving object has energy of motion.</a:t>
-            </a:r>
-          </a:p>
-        </p:txBody>
-      </p:sp>
-      <p:sp>
-        <p:nvSpPr>
-          <p:cNvPr id="5" name="TextBox 4"/>
+              <a:t>NOTES</a:t>
+            </a:r>
+          </a:p>
+        </p:txBody>
+      </p:sp>
+      <p:sp>
+        <p:nvSpPr>
+          <p:cNvPr id="5" name="Rounded Rectangle 4"/>
+          <p:cNvSpPr/>
+          <p:nvPr/>
+        </p:nvSpPr>
+        <p:spPr>
+          <a:xfrm>
+            <a:off x="1097280" y="1737360"/>
+            <a:ext cx="9966960" cy="1234440"/>
+          </a:xfrm>
+          <a:prstGeom prst="roundRect">
+            <a:avLst/>
+          </a:prstGeom>
+          <a:solidFill>
+            <a:srgbClr val="E8EDF4"/>
+          </a:solidFill>
+          <a:ln>
+            <a:noFill/>
+          </a:ln>
+        </p:spPr>
+        <p:style>
+          <a:lnRef idx="1">
+            <a:schemeClr val="accent1"/>
+          </a:lnRef>
+          <a:fillRef idx="3">
+            <a:schemeClr val="accent1"/>
+          </a:fillRef>
+          <a:effectRef idx="2">
+            <a:schemeClr val="accent1"/>
+          </a:effectRef>
+          <a:fontRef idx="minor">
+            <a:schemeClr val="lt1"/>
+          </a:fontRef>
+        </p:style>
+        <p:txBody>
+          <a:bodyPr rtlCol="0" anchor="ctr" wrap="square"/>
+          <a:lstStyle/>
+          <a:p>
+            <a:pPr algn="ctr"/>
+          </a:p>
+        </p:txBody>
+      </p:sp>
+      <p:sp>
+        <p:nvSpPr>
+          <p:cNvPr id="6" name="TextBox 5"/>
           <p:cNvSpPr txBox="1"/>
           <p:nvPr/>
         </p:nvSpPr>
         <p:spPr>
           <a:xfrm>
-            <a:off x="11338560" y="6446520"/>
-            <a:ext cx="731520" cy="365760"/>
+            <a:off x="1371600" y="1828800"/>
+            <a:ext cx="9418320" cy="457200"/>
           </a:xfrm>
           <a:prstGeom prst="rect">
             <a:avLst/>
@@ -3819,15 +3862,233 @@
           </a:bodyPr>
           <a:lstStyle/>
           <a:p>
-            <a:pPr algn="r"/>
-            <a:r>
-              <a:rPr sz="1200" b="0">
+            <a:pPr algn="l"/>
+            <a:r>
+              <a:rPr sz="1600" b="1" i="0">
+                <a:solidFill>
+                  <a:srgbClr val="C05014"/>
+                </a:solidFill>
+                <a:latin typeface="Arial"/>
+              </a:rPr>
+              <a:t>WRITE:</a:t>
+            </a:r>
+          </a:p>
+        </p:txBody>
+      </p:sp>
+      <p:sp>
+        <p:nvSpPr>
+          <p:cNvPr id="7" name="TextBox 6"/>
+          <p:cNvSpPr txBox="1"/>
+          <p:nvPr/>
+        </p:nvSpPr>
+        <p:spPr>
+          <a:xfrm>
+            <a:off x="1371600" y="2240280"/>
+            <a:ext cx="9418320" cy="640080"/>
+          </a:xfrm>
+          <a:prstGeom prst="rect">
+            <a:avLst/>
+          </a:prstGeom>
+          <a:noFill/>
+        </p:spPr>
+        <p:txBody>
+          <a:bodyPr wrap="square" anchor="t">
+            <a:spAutoFit/>
+          </a:bodyPr>
+          <a:lstStyle/>
+          <a:p>
+            <a:pPr algn="l"/>
+            <a:r>
+              <a:rPr sz="2800" b="1" i="0">
+                <a:solidFill>
+                  <a:srgbClr val="1F3A5F"/>
+                </a:solidFill>
+                <a:latin typeface="Arial"/>
+              </a:rPr>
+              <a:t>An object is in motion when its position changes.</a:t>
+            </a:r>
+          </a:p>
+        </p:txBody>
+      </p:sp>
+      <p:sp>
+        <p:nvSpPr>
+          <p:cNvPr id="8" name="TextBox 7"/>
+          <p:cNvSpPr txBox="1"/>
+          <p:nvPr/>
+        </p:nvSpPr>
+        <p:spPr>
+          <a:xfrm>
+            <a:off x="1371600" y="3017520"/>
+            <a:ext cx="9418320" cy="457200"/>
+          </a:xfrm>
+          <a:prstGeom prst="rect">
+            <a:avLst/>
+          </a:prstGeom>
+          <a:noFill/>
+        </p:spPr>
+        <p:txBody>
+          <a:bodyPr wrap="square" anchor="t">
+            <a:spAutoFit/>
+          </a:bodyPr>
+          <a:lstStyle/>
+          <a:p>
+            <a:pPr algn="l"/>
+            <a:r>
+              <a:rPr sz="1600" b="0" i="1">
                 <a:solidFill>
                   <a:srgbClr val="555555"/>
                 </a:solidFill>
                 <a:latin typeface="Arial"/>
               </a:rPr>
-              <a:t>11</a:t>
+              <a:t>REVEAL → POSITION</a:t>
+            </a:r>
+          </a:p>
+        </p:txBody>
+      </p:sp>
+      <p:sp>
+        <p:nvSpPr>
+          <p:cNvPr id="9" name="Rounded Rectangle 8"/>
+          <p:cNvSpPr/>
+          <p:nvPr/>
+        </p:nvSpPr>
+        <p:spPr>
+          <a:xfrm>
+            <a:off x="1097280" y="4206240"/>
+            <a:ext cx="9966960" cy="1828800"/>
+          </a:xfrm>
+          <a:prstGeom prst="roundRect">
+            <a:avLst/>
+          </a:prstGeom>
+          <a:solidFill>
+            <a:srgbClr val="2E6B3F"/>
+          </a:solidFill>
+          <a:ln>
+            <a:noFill/>
+          </a:ln>
+        </p:spPr>
+        <p:style>
+          <a:lnRef idx="1">
+            <a:schemeClr val="accent1"/>
+          </a:lnRef>
+          <a:fillRef idx="3">
+            <a:schemeClr val="accent1"/>
+          </a:fillRef>
+          <a:effectRef idx="2">
+            <a:schemeClr val="accent1"/>
+          </a:effectRef>
+          <a:fontRef idx="minor">
+            <a:schemeClr val="lt1"/>
+          </a:fontRef>
+        </p:style>
+        <p:txBody>
+          <a:bodyPr rtlCol="0" anchor="ctr" wrap="square"/>
+          <a:lstStyle/>
+          <a:p>
+            <a:pPr algn="ctr"/>
+          </a:p>
+        </p:txBody>
+      </p:sp>
+      <p:sp>
+        <p:nvSpPr>
+          <p:cNvPr id="10" name="TextBox 9"/>
+          <p:cNvSpPr txBox="1"/>
+          <p:nvPr/>
+        </p:nvSpPr>
+        <p:spPr>
+          <a:xfrm>
+            <a:off x="1371600" y="4297679"/>
+            <a:ext cx="9418320" cy="457200"/>
+          </a:xfrm>
+          <a:prstGeom prst="rect">
+            <a:avLst/>
+          </a:prstGeom>
+          <a:noFill/>
+        </p:spPr>
+        <p:txBody>
+          <a:bodyPr wrap="square" anchor="t">
+            <a:spAutoFit/>
+          </a:bodyPr>
+          <a:lstStyle/>
+          <a:p>
+            <a:pPr algn="l"/>
+            <a:r>
+              <a:rPr sz="1600" b="1" i="0">
+                <a:solidFill>
+                  <a:srgbClr val="FFFFFF"/>
+                </a:solidFill>
+                <a:latin typeface="Arial"/>
+              </a:rPr>
+              <a:t>DRAWING IDEAS (draw YOUR example):</a:t>
+            </a:r>
+          </a:p>
+        </p:txBody>
+      </p:sp>
+      <p:sp>
+        <p:nvSpPr>
+          <p:cNvPr id="11" name="TextBox 10"/>
+          <p:cNvSpPr txBox="1"/>
+          <p:nvPr/>
+        </p:nvSpPr>
+        <p:spPr>
+          <a:xfrm>
+            <a:off x="1463040" y="4754879"/>
+            <a:ext cx="9418320" cy="411480"/>
+          </a:xfrm>
+          <a:prstGeom prst="rect">
+            <a:avLst/>
+          </a:prstGeom>
+          <a:noFill/>
+        </p:spPr>
+        <p:txBody>
+          <a:bodyPr wrap="square" anchor="t">
+            <a:spAutoFit/>
+          </a:bodyPr>
+          <a:lstStyle/>
+          <a:p>
+            <a:pPr algn="l"/>
+            <a:r>
+              <a:rPr sz="1800" b="0" i="0">
+                <a:solidFill>
+                  <a:srgbClr val="FFFFFF"/>
+                </a:solidFill>
+                <a:latin typeface="Arial"/>
+              </a:rPr>
+              <a:t>•  draw a moving object</a:t>
+            </a:r>
+          </a:p>
+        </p:txBody>
+      </p:sp>
+      <p:sp>
+        <p:nvSpPr>
+          <p:cNvPr id="12" name="TextBox 11"/>
+          <p:cNvSpPr txBox="1"/>
+          <p:nvPr/>
+        </p:nvSpPr>
+        <p:spPr>
+          <a:xfrm>
+            <a:off x="1463040" y="5166359"/>
+            <a:ext cx="9418320" cy="411480"/>
+          </a:xfrm>
+          <a:prstGeom prst="rect">
+            <a:avLst/>
+          </a:prstGeom>
+          <a:noFill/>
+        </p:spPr>
+        <p:txBody>
+          <a:bodyPr wrap="square" anchor="t">
+            <a:spAutoFit/>
+          </a:bodyPr>
+          <a:lstStyle/>
+          <a:p>
+            <a:pPr algn="l"/>
+            <a:r>
+              <a:rPr sz="1800" b="0" i="0">
+                <a:solidFill>
+                  <a:srgbClr val="FFFFFF"/>
+                </a:solidFill>
+                <a:latin typeface="Arial"/>
+              </a:rPr>
+              <a:t>•  add an arrow to show direction</a:t>
             </a:r>
           </a:p>
         </p:txBody>
@@ -3923,62 +4184,27 @@
                 </a:solidFill>
                 <a:latin typeface="Arial"/>
               </a:rPr>
-              <a:t>Our investigation</a:t>
-            </a:r>
-          </a:p>
-        </p:txBody>
-      </p:sp>
-      <p:sp>
-        <p:nvSpPr>
-          <p:cNvPr id="4" name="TextBox 3"/>
-          <p:cNvSpPr txBox="1"/>
-          <p:nvPr/>
-        </p:nvSpPr>
-        <p:spPr>
-          <a:xfrm>
-            <a:off x="502920" y="1170432"/>
-            <a:ext cx="11247120" cy="457200"/>
-          </a:xfrm>
-          <a:prstGeom prst="rect">
-            <a:avLst/>
-          </a:prstGeom>
-          <a:noFill/>
-        </p:spPr>
-        <p:txBody>
-          <a:bodyPr wrap="square" anchor="t">
-            <a:spAutoFit/>
-          </a:bodyPr>
-          <a:lstStyle/>
-          <a:p>
-            <a:pPr algn="l"/>
-            <a:r>
-              <a:rPr sz="1600" b="0">
-                <a:solidFill>
-                  <a:srgbClr val="555555"/>
-                </a:solidFill>
-                <a:latin typeface="Arial"/>
-              </a:rPr>
-              <a:t>Lab</a:t>
-            </a:r>
-          </a:p>
-        </p:txBody>
-      </p:sp>
-      <p:sp>
-        <p:nvSpPr>
-          <p:cNvPr id="5" name="Rounded Rectangle 4"/>
+              <a:t>Energy of motion</a:t>
+            </a:r>
+          </a:p>
+        </p:txBody>
+      </p:sp>
+      <p:sp>
+        <p:nvSpPr>
+          <p:cNvPr id="4" name="Rounded Rectangle 3"/>
           <p:cNvSpPr/>
           <p:nvPr/>
         </p:nvSpPr>
         <p:spPr>
           <a:xfrm>
-            <a:off x="822960" y="2194560"/>
-            <a:ext cx="10515600" cy="2011680"/>
+            <a:off x="1097280" y="2377440"/>
+            <a:ext cx="9966960" cy="1737360"/>
           </a:xfrm>
           <a:prstGeom prst="roundRect">
             <a:avLst/>
           </a:prstGeom>
           <a:solidFill>
-            <a:srgbClr val="E8EDF4"/>
+            <a:srgbClr val="C05014"/>
           </a:solidFill>
           <a:ln>
             <a:noFill/>
@@ -4006,18 +4232,18 @@
             <a:r>
               <a:rPr sz="3000" b="1">
                 <a:solidFill>
-                  <a:srgbClr val="1F3A5F"/>
-                </a:solidFill>
-                <a:latin typeface="Arial"/>
-              </a:rPr>
-              <a:t>How does a moving marble provide evidence that it has energy?</a:t>
-            </a:r>
-          </a:p>
-        </p:txBody>
-      </p:sp>
-      <p:sp>
-        <p:nvSpPr>
-          <p:cNvPr id="6" name="TextBox 5"/>
+                  <a:srgbClr val="FFFFFF"/>
+                </a:solidFill>
+                <a:latin typeface="Arial"/>
+              </a:rPr>
+              <a:t>A moving object has energy of motion.</a:t>
+            </a:r>
+          </a:p>
+        </p:txBody>
+      </p:sp>
+      <p:sp>
+        <p:nvSpPr>
+          <p:cNvPr id="5" name="TextBox 4"/>
           <p:cNvSpPr txBox="1"/>
           <p:nvPr/>
         </p:nvSpPr>
@@ -4045,7 +4271,7 @@
                 </a:solidFill>
                 <a:latin typeface="Arial"/>
               </a:rPr>
-              <a:t>12</a:t>
+              <a:t>11</a:t>
             </a:r>
           </a:p>
         </p:txBody>
@@ -4120,7 +4346,7 @@
         <p:spPr>
           <a:xfrm>
             <a:off x="457200" y="146304"/>
-            <a:ext cx="11247120" cy="777240"/>
+            <a:ext cx="10058400" cy="777240"/>
           </a:xfrm>
           <a:prstGeom prst="rect">
             <a:avLst/>
@@ -4135,48 +4361,65 @@
           <a:p>
             <a:pPr algn="l"/>
             <a:r>
-              <a:rPr sz="3400" b="1">
+              <a:rPr sz="3400" b="1" i="0">
                 <a:solidFill>
                   <a:srgbClr val="FFFFFF"/>
                 </a:solidFill>
                 <a:latin typeface="Arial"/>
               </a:rPr>
-              <a:t>Setup</a:t>
-            </a:r>
-          </a:p>
-        </p:txBody>
-      </p:sp>
-      <p:sp>
-        <p:nvSpPr>
-          <p:cNvPr id="4" name="TextBox 3"/>
-          <p:cNvSpPr txBox="1"/>
-          <p:nvPr/>
-        </p:nvSpPr>
-        <p:spPr>
-          <a:xfrm>
-            <a:off x="502920" y="1170432"/>
-            <a:ext cx="11247120" cy="457200"/>
-          </a:xfrm>
-          <a:prstGeom prst="rect">
-            <a:avLst/>
-          </a:prstGeom>
-          <a:noFill/>
-        </p:spPr>
-        <p:txBody>
-          <a:bodyPr wrap="square" anchor="t">
-            <a:spAutoFit/>
-          </a:bodyPr>
-          <a:lstStyle/>
-          <a:p>
-            <a:pPr algn="l"/>
-            <a:r>
-              <a:rPr sz="1600" b="0">
-                <a:solidFill>
-                  <a:srgbClr val="555555"/>
-                </a:solidFill>
-                <a:latin typeface="Arial"/>
-              </a:rPr>
-              <a:t>Lab</a:t>
+              <a:t>Notes — Energy of Motion</a:t>
+            </a:r>
+          </a:p>
+        </p:txBody>
+      </p:sp>
+      <p:sp>
+        <p:nvSpPr>
+          <p:cNvPr id="4" name="Rounded Rectangle 3"/>
+          <p:cNvSpPr/>
+          <p:nvPr/>
+        </p:nvSpPr>
+        <p:spPr>
+          <a:xfrm>
+            <a:off x="9692640" y="256032"/>
+            <a:ext cx="2103120" cy="548640"/>
+          </a:xfrm>
+          <a:prstGeom prst="roundRect">
+            <a:avLst/>
+          </a:prstGeom>
+          <a:solidFill>
+            <a:srgbClr val="C05014"/>
+          </a:solidFill>
+          <a:ln>
+            <a:noFill/>
+          </a:ln>
+        </p:spPr>
+        <p:style>
+          <a:lnRef idx="1">
+            <a:schemeClr val="accent1"/>
+          </a:lnRef>
+          <a:fillRef idx="3">
+            <a:schemeClr val="accent1"/>
+          </a:fillRef>
+          <a:effectRef idx="2">
+            <a:schemeClr val="accent1"/>
+          </a:effectRef>
+          <a:fontRef idx="minor">
+            <a:schemeClr val="lt1"/>
+          </a:fontRef>
+        </p:style>
+        <p:txBody>
+          <a:bodyPr rtlCol="0" anchor="ctr" wrap="square"/>
+          <a:lstStyle/>
+          <a:p>
+            <a:pPr algn="ctr"/>
+            <a:r>
+              <a:rPr sz="1800" b="1">
+                <a:solidFill>
+                  <a:srgbClr val="FFFFFF"/>
+                </a:solidFill>
+                <a:latin typeface="Arial"/>
+              </a:rPr>
+              <a:t>NOTES</a:t>
             </a:r>
           </a:p>
         </p:txBody>
@@ -4189,8 +4432,8 @@
         </p:nvSpPr>
         <p:spPr>
           <a:xfrm>
-            <a:off x="1371600" y="2103120"/>
-            <a:ext cx="9418320" cy="914400"/>
+            <a:off x="1097280" y="1737360"/>
+            <a:ext cx="9966960" cy="1234440"/>
           </a:xfrm>
           <a:prstGeom prst="roundRect">
             <a:avLst/>
@@ -4220,35 +4463,131 @@
           <a:bodyPr rtlCol="0" anchor="ctr" wrap="square"/>
           <a:lstStyle/>
           <a:p>
+            <a:pPr algn="ctr"/>
+          </a:p>
+        </p:txBody>
+      </p:sp>
+      <p:sp>
+        <p:nvSpPr>
+          <p:cNvPr id="6" name="TextBox 5"/>
+          <p:cNvSpPr txBox="1"/>
+          <p:nvPr/>
+        </p:nvSpPr>
+        <p:spPr>
+          <a:xfrm>
+            <a:off x="1371600" y="1828800"/>
+            <a:ext cx="9418320" cy="457200"/>
+          </a:xfrm>
+          <a:prstGeom prst="rect">
+            <a:avLst/>
+          </a:prstGeom>
+          <a:noFill/>
+        </p:spPr>
+        <p:txBody>
+          <a:bodyPr wrap="square" anchor="t">
+            <a:spAutoFit/>
+          </a:bodyPr>
+          <a:lstStyle/>
+          <a:p>
             <a:pPr algn="l"/>
             <a:r>
-              <a:rPr sz="2400" b="1">
+              <a:rPr sz="1600" b="1" i="0">
+                <a:solidFill>
+                  <a:srgbClr val="C05014"/>
+                </a:solidFill>
+                <a:latin typeface="Arial"/>
+              </a:rPr>
+              <a:t>WRITE:</a:t>
+            </a:r>
+          </a:p>
+        </p:txBody>
+      </p:sp>
+      <p:sp>
+        <p:nvSpPr>
+          <p:cNvPr id="7" name="TextBox 6"/>
+          <p:cNvSpPr txBox="1"/>
+          <p:nvPr/>
+        </p:nvSpPr>
+        <p:spPr>
+          <a:xfrm>
+            <a:off x="1371600" y="2240280"/>
+            <a:ext cx="9418320" cy="640080"/>
+          </a:xfrm>
+          <a:prstGeom prst="rect">
+            <a:avLst/>
+          </a:prstGeom>
+          <a:noFill/>
+        </p:spPr>
+        <p:txBody>
+          <a:bodyPr wrap="square" anchor="t">
+            <a:spAutoFit/>
+          </a:bodyPr>
+          <a:lstStyle/>
+          <a:p>
+            <a:pPr algn="l"/>
+            <a:r>
+              <a:rPr sz="2800" b="1" i="0">
                 <a:solidFill>
                   <a:srgbClr val="1F3A5F"/>
                 </a:solidFill>
                 <a:latin typeface="Arial"/>
               </a:rPr>
-              <a:t>•  One moving marble</a:t>
-            </a:r>
-          </a:p>
-        </p:txBody>
-      </p:sp>
-      <p:sp>
-        <p:nvSpPr>
-          <p:cNvPr id="6" name="Rounded Rectangle 5"/>
+              <a:t>A moving object has energy of motion.</a:t>
+            </a:r>
+          </a:p>
+        </p:txBody>
+      </p:sp>
+      <p:sp>
+        <p:nvSpPr>
+          <p:cNvPr id="8" name="TextBox 7"/>
+          <p:cNvSpPr txBox="1"/>
+          <p:nvPr/>
+        </p:nvSpPr>
+        <p:spPr>
+          <a:xfrm>
+            <a:off x="1371600" y="3017520"/>
+            <a:ext cx="9418320" cy="457200"/>
+          </a:xfrm>
+          <a:prstGeom prst="rect">
+            <a:avLst/>
+          </a:prstGeom>
+          <a:noFill/>
+        </p:spPr>
+        <p:txBody>
+          <a:bodyPr wrap="square" anchor="t">
+            <a:spAutoFit/>
+          </a:bodyPr>
+          <a:lstStyle/>
+          <a:p>
+            <a:pPr algn="l"/>
+            <a:r>
+              <a:rPr sz="1600" b="0" i="1">
+                <a:solidFill>
+                  <a:srgbClr val="555555"/>
+                </a:solidFill>
+                <a:latin typeface="Arial"/>
+              </a:rPr>
+              <a:t>REVEAL → MOTION</a:t>
+            </a:r>
+          </a:p>
+        </p:txBody>
+      </p:sp>
+      <p:sp>
+        <p:nvSpPr>
+          <p:cNvPr id="9" name="Rounded Rectangle 8"/>
           <p:cNvSpPr/>
           <p:nvPr/>
         </p:nvSpPr>
         <p:spPr>
           <a:xfrm>
-            <a:off x="1371600" y="3291839"/>
-            <a:ext cx="9418320" cy="914400"/>
+            <a:off x="1097280" y="4206240"/>
+            <a:ext cx="9966960" cy="1828800"/>
           </a:xfrm>
           <a:prstGeom prst="roundRect">
             <a:avLst/>
           </a:prstGeom>
           <a:solidFill>
-            <a:srgbClr val="E8EDF4"/>
+            <a:srgbClr val="2E6B3F"/>
           </a:solidFill>
           <a:ln>
             <a:noFill/>
@@ -4272,81 +4611,20 @@
           <a:bodyPr rtlCol="0" anchor="ctr" wrap="square"/>
           <a:lstStyle/>
           <a:p>
-            <a:pPr algn="l"/>
-            <a:r>
-              <a:rPr sz="2400" b="1">
-                <a:solidFill>
-                  <a:srgbClr val="1F3A5F"/>
-                </a:solidFill>
-                <a:latin typeface="Arial"/>
-              </a:rPr>
-              <a:t>•  One target marble at rest</a:t>
-            </a:r>
-          </a:p>
-        </p:txBody>
-      </p:sp>
-      <p:sp>
-        <p:nvSpPr>
-          <p:cNvPr id="7" name="Rounded Rectangle 6"/>
-          <p:cNvSpPr/>
-          <p:nvPr/>
-        </p:nvSpPr>
-        <p:spPr>
-          <a:xfrm>
-            <a:off x="1371600" y="4480560"/>
-            <a:ext cx="9418320" cy="914400"/>
-          </a:xfrm>
-          <a:prstGeom prst="roundRect">
-            <a:avLst/>
-          </a:prstGeom>
-          <a:solidFill>
-            <a:srgbClr val="E8EDF4"/>
-          </a:solidFill>
-          <a:ln>
-            <a:noFill/>
-          </a:ln>
-        </p:spPr>
-        <p:style>
-          <a:lnRef idx="1">
-            <a:schemeClr val="accent1"/>
-          </a:lnRef>
-          <a:fillRef idx="3">
-            <a:schemeClr val="accent1"/>
-          </a:fillRef>
-          <a:effectRef idx="2">
-            <a:schemeClr val="accent1"/>
-          </a:effectRef>
-          <a:fontRef idx="minor">
-            <a:schemeClr val="lt1"/>
-          </a:fontRef>
-        </p:style>
-        <p:txBody>
-          <a:bodyPr rtlCol="0" anchor="ctr" wrap="square"/>
-          <a:lstStyle/>
-          <a:p>
-            <a:pPr algn="l"/>
-            <a:r>
-              <a:rPr sz="2400" b="1">
-                <a:solidFill>
-                  <a:srgbClr val="1F3A5F"/>
-                </a:solidFill>
-                <a:latin typeface="Arial"/>
-              </a:rPr>
-              <a:t>•  Identical marbles · flat surface</a:t>
-            </a:r>
-          </a:p>
-        </p:txBody>
-      </p:sp>
-      <p:sp>
-        <p:nvSpPr>
-          <p:cNvPr id="8" name="TextBox 7"/>
+            <a:pPr algn="ctr"/>
+          </a:p>
+        </p:txBody>
+      </p:sp>
+      <p:sp>
+        <p:nvSpPr>
+          <p:cNvPr id="10" name="TextBox 9"/>
           <p:cNvSpPr txBox="1"/>
           <p:nvPr/>
         </p:nvSpPr>
         <p:spPr>
           <a:xfrm>
-            <a:off x="11338560" y="6446520"/>
-            <a:ext cx="731520" cy="365760"/>
+            <a:off x="1371600" y="4297679"/>
+            <a:ext cx="9418320" cy="457200"/>
           </a:xfrm>
           <a:prstGeom prst="rect">
             <a:avLst/>
@@ -4359,15 +4637,50 @@
           </a:bodyPr>
           <a:lstStyle/>
           <a:p>
-            <a:pPr algn="r"/>
-            <a:r>
-              <a:rPr sz="1200" b="0">
-                <a:solidFill>
-                  <a:srgbClr val="555555"/>
-                </a:solidFill>
-                <a:latin typeface="Arial"/>
-              </a:rPr>
-              <a:t>13</a:t>
+            <a:pPr algn="l"/>
+            <a:r>
+              <a:rPr sz="1600" b="1" i="0">
+                <a:solidFill>
+                  <a:srgbClr val="FFFFFF"/>
+                </a:solidFill>
+                <a:latin typeface="Arial"/>
+              </a:rPr>
+              <a:t>DRAWING IDEAS (draw YOUR example):</a:t>
+            </a:r>
+          </a:p>
+        </p:txBody>
+      </p:sp>
+      <p:sp>
+        <p:nvSpPr>
+          <p:cNvPr id="11" name="TextBox 10"/>
+          <p:cNvSpPr txBox="1"/>
+          <p:nvPr/>
+        </p:nvSpPr>
+        <p:spPr>
+          <a:xfrm>
+            <a:off x="1463040" y="4754879"/>
+            <a:ext cx="9418320" cy="411480"/>
+          </a:xfrm>
+          <a:prstGeom prst="rect">
+            <a:avLst/>
+          </a:prstGeom>
+          <a:noFill/>
+        </p:spPr>
+        <p:txBody>
+          <a:bodyPr wrap="square" anchor="t">
+            <a:spAutoFit/>
+          </a:bodyPr>
+          <a:lstStyle/>
+          <a:p>
+            <a:pPr algn="l"/>
+            <a:r>
+              <a:rPr sz="1800" b="0" i="0">
+                <a:solidFill>
+                  <a:srgbClr val="FFFFFF"/>
+                </a:solidFill>
+                <a:latin typeface="Arial"/>
+              </a:rPr>
+              <a:t>•  draw a moving object causing something else to change</a:t>
             </a:r>
           </a:p>
         </p:txBody>
@@ -4463,7 +4776,7 @@
                 </a:solidFill>
                 <a:latin typeface="Arial"/>
               </a:rPr>
-              <a:t>Predict</a:t>
+              <a:t>Our investigation</a:t>
             </a:r>
           </a:p>
         </p:txBody>
@@ -4511,8 +4824,8 @@
         </p:nvSpPr>
         <p:spPr>
           <a:xfrm>
-            <a:off x="1097280" y="2377440"/>
-            <a:ext cx="9966960" cy="1828800"/>
+            <a:off x="822960" y="2194560"/>
+            <a:ext cx="10515600" cy="2011680"/>
           </a:xfrm>
           <a:prstGeom prst="roundRect">
             <a:avLst/>
@@ -4544,13 +4857,13 @@
           <a:p>
             <a:pPr algn="ctr"/>
             <a:r>
-              <a:rPr sz="2800" b="1">
+              <a:rPr sz="3000" b="1">
                 <a:solidFill>
                   <a:srgbClr val="1F3A5F"/>
                 </a:solidFill>
                 <a:latin typeface="Arial"/>
               </a:rPr>
-              <a:t>Predict: what will happen when the marble reaches the target?</a:t>
+              <a:t>How does a moving marble provide evidence that it has energy?</a:t>
             </a:r>
           </a:p>
         </p:txBody>
@@ -4585,7 +4898,7 @@
                 </a:solidFill>
                 <a:latin typeface="Arial"/>
               </a:rPr>
-              <a:t>14</a:t>
+              <a:t>12</a:t>
             </a:r>
           </a:p>
         </p:txBody>
@@ -4681,7 +4994,7 @@
                 </a:solidFill>
                 <a:latin typeface="Arial"/>
               </a:rPr>
-              <a:t>Procedure</a:t>
+              <a:t>Setup</a:t>
             </a:r>
           </a:p>
         </p:txBody>
@@ -4762,13 +5075,13 @@
           <a:p>
             <a:pPr algn="l"/>
             <a:r>
-              <a:rPr sz="2600" b="1">
+              <a:rPr sz="2400" b="1">
                 <a:solidFill>
                   <a:srgbClr val="1F3A5F"/>
                 </a:solidFill>
                 <a:latin typeface="Arial"/>
               </a:rPr>
-              <a:t>1.  Roll the moving marble toward the target.</a:t>
+              <a:t>•  One moving marble</a:t>
             </a:r>
           </a:p>
         </p:txBody>
@@ -4814,13 +5127,13 @@
           <a:p>
             <a:pPr algn="l"/>
             <a:r>
-              <a:rPr sz="2600" b="1">
+              <a:rPr sz="2400" b="1">
                 <a:solidFill>
                   <a:srgbClr val="1F3A5F"/>
                 </a:solidFill>
                 <a:latin typeface="Arial"/>
               </a:rPr>
-              <a:t>2.  Observe what the target does.</a:t>
+              <a:t>•  One target marble at rest</a:t>
             </a:r>
           </a:p>
         </p:txBody>
@@ -4866,13 +5179,13 @@
           <a:p>
             <a:pPr algn="l"/>
             <a:r>
-              <a:rPr sz="2600" b="1">
+              <a:rPr sz="2400" b="1">
                 <a:solidFill>
                   <a:srgbClr val="1F3A5F"/>
                 </a:solidFill>
                 <a:latin typeface="Arial"/>
               </a:rPr>
-              <a:t>3.  Record what changed.</a:t>
+              <a:t>•  Identical marbles · flat surface</a:t>
             </a:r>
           </a:p>
         </p:txBody>
@@ -4907,7 +5220,7 @@
                 </a:solidFill>
                 <a:latin typeface="Arial"/>
               </a:rPr>
-              <a:t>15</a:t>
+              <a:t>13</a:t>
             </a:r>
           </a:p>
         </p:txBody>
@@ -5003,7 +5316,7 @@
                 </a:solidFill>
                 <a:latin typeface="Arial"/>
               </a:rPr>
-              <a:t>Record your evidence</a:t>
+              <a:t>Predict</a:t>
             </a:r>
           </a:p>
         </p:txBody>
@@ -5051,8 +5364,8 @@
         </p:nvSpPr>
         <p:spPr>
           <a:xfrm>
-            <a:off x="822960" y="2194560"/>
-            <a:ext cx="10515600" cy="2926080"/>
+            <a:off x="1097280" y="2377440"/>
+            <a:ext cx="9966960" cy="1828800"/>
           </a:xfrm>
           <a:prstGeom prst="roundRect">
             <a:avLst/>
@@ -5083,6 +5396,15 @@
           <a:lstStyle/>
           <a:p>
             <a:pPr algn="ctr"/>
+            <a:r>
+              <a:rPr sz="2800" b="1">
+                <a:solidFill>
+                  <a:srgbClr val="1F3A5F"/>
+                </a:solidFill>
+                <a:latin typeface="Arial"/>
+              </a:rPr>
+              <a:t>Predict: what will happen when the marble reaches the target?</a:t>
+            </a:r>
           </a:p>
         </p:txBody>
       </p:sp>
@@ -5094,8 +5416,8 @@
         </p:nvSpPr>
         <p:spPr>
           <a:xfrm>
-            <a:off x="1371600" y="2468880"/>
-            <a:ext cx="9418320" cy="731520"/>
+            <a:off x="11338560" y="6446520"/>
+            <a:ext cx="731520" cy="365760"/>
           </a:xfrm>
           <a:prstGeom prst="rect">
             <a:avLst/>
@@ -5108,111 +5430,6 @@
           </a:bodyPr>
           <a:lstStyle/>
           <a:p>
-            <a:pPr algn="l"/>
-            <a:r>
-              <a:rPr sz="2400" b="0">
-                <a:solidFill>
-                  <a:srgbClr val="1F3A5F"/>
-                </a:solidFill>
-                <a:latin typeface="Arial"/>
-              </a:rPr>
-              <a:t>What moved before?</a:t>
-            </a:r>
-          </a:p>
-        </p:txBody>
-      </p:sp>
-      <p:sp>
-        <p:nvSpPr>
-          <p:cNvPr id="7" name="TextBox 6"/>
-          <p:cNvSpPr txBox="1"/>
-          <p:nvPr/>
-        </p:nvSpPr>
-        <p:spPr>
-          <a:xfrm>
-            <a:off x="1371600" y="3337560"/>
-            <a:ext cx="9418320" cy="731520"/>
-          </a:xfrm>
-          <a:prstGeom prst="rect">
-            <a:avLst/>
-          </a:prstGeom>
-          <a:noFill/>
-        </p:spPr>
-        <p:txBody>
-          <a:bodyPr wrap="square" anchor="t">
-            <a:spAutoFit/>
-          </a:bodyPr>
-          <a:lstStyle/>
-          <a:p>
-            <a:pPr algn="l"/>
-            <a:r>
-              <a:rPr sz="2400" b="0">
-                <a:solidFill>
-                  <a:srgbClr val="1F3A5F"/>
-                </a:solidFill>
-                <a:latin typeface="Arial"/>
-              </a:rPr>
-              <a:t>What changed after contact?</a:t>
-            </a:r>
-          </a:p>
-        </p:txBody>
-      </p:sp>
-      <p:sp>
-        <p:nvSpPr>
-          <p:cNvPr id="8" name="TextBox 7"/>
-          <p:cNvSpPr txBox="1"/>
-          <p:nvPr/>
-        </p:nvSpPr>
-        <p:spPr>
-          <a:xfrm>
-            <a:off x="1371600" y="4206240"/>
-            <a:ext cx="9418320" cy="731520"/>
-          </a:xfrm>
-          <a:prstGeom prst="rect">
-            <a:avLst/>
-          </a:prstGeom>
-          <a:noFill/>
-        </p:spPr>
-        <p:txBody>
-          <a:bodyPr wrap="square" anchor="t">
-            <a:spAutoFit/>
-          </a:bodyPr>
-          <a:lstStyle/>
-          <a:p>
-            <a:pPr algn="l"/>
-            <a:r>
-              <a:rPr sz="2400" b="0">
-                <a:solidFill>
-                  <a:srgbClr val="1F3A5F"/>
-                </a:solidFill>
-                <a:latin typeface="Arial"/>
-              </a:rPr>
-              <a:t>How did the target change?</a:t>
-            </a:r>
-          </a:p>
-        </p:txBody>
-      </p:sp>
-      <p:sp>
-        <p:nvSpPr>
-          <p:cNvPr id="9" name="TextBox 8"/>
-          <p:cNvSpPr txBox="1"/>
-          <p:nvPr/>
-        </p:nvSpPr>
-        <p:spPr>
-          <a:xfrm>
-            <a:off x="11338560" y="6446520"/>
-            <a:ext cx="731520" cy="365760"/>
-          </a:xfrm>
-          <a:prstGeom prst="rect">
-            <a:avLst/>
-          </a:prstGeom>
-          <a:noFill/>
-        </p:spPr>
-        <p:txBody>
-          <a:bodyPr wrap="square" anchor="t">
-            <a:spAutoFit/>
-          </a:bodyPr>
-          <a:lstStyle/>
-          <a:p>
             <a:pPr algn="r"/>
             <a:r>
               <a:rPr sz="1200" b="0">
@@ -5221,7 +5438,7 @@
                 </a:solidFill>
                 <a:latin typeface="Arial"/>
               </a:rPr>
-              <a:t>16</a:t>
+              <a:t>14</a:t>
             </a:r>
           </a:p>
         </p:txBody>
@@ -5317,21 +5534,56 @@
                 </a:solidFill>
                 <a:latin typeface="Arial"/>
               </a:rPr>
-              <a:t>Debrief</a:t>
-            </a:r>
-          </a:p>
-        </p:txBody>
-      </p:sp>
-      <p:sp>
-        <p:nvSpPr>
-          <p:cNvPr id="4" name="Rounded Rectangle 3"/>
+              <a:t>Procedure</a:t>
+            </a:r>
+          </a:p>
+        </p:txBody>
+      </p:sp>
+      <p:sp>
+        <p:nvSpPr>
+          <p:cNvPr id="4" name="TextBox 3"/>
+          <p:cNvSpPr txBox="1"/>
+          <p:nvPr/>
+        </p:nvSpPr>
+        <p:spPr>
+          <a:xfrm>
+            <a:off x="502920" y="1170432"/>
+            <a:ext cx="11247120" cy="457200"/>
+          </a:xfrm>
+          <a:prstGeom prst="rect">
+            <a:avLst/>
+          </a:prstGeom>
+          <a:noFill/>
+        </p:spPr>
+        <p:txBody>
+          <a:bodyPr wrap="square" anchor="t">
+            <a:spAutoFit/>
+          </a:bodyPr>
+          <a:lstStyle/>
+          <a:p>
+            <a:pPr algn="l"/>
+            <a:r>
+              <a:rPr sz="1600" b="0">
+                <a:solidFill>
+                  <a:srgbClr val="555555"/>
+                </a:solidFill>
+                <a:latin typeface="Arial"/>
+              </a:rPr>
+              <a:t>Lab</a:t>
+            </a:r>
+          </a:p>
+        </p:txBody>
+      </p:sp>
+      <p:sp>
+        <p:nvSpPr>
+          <p:cNvPr id="5" name="Rounded Rectangle 4"/>
           <p:cNvSpPr/>
           <p:nvPr/>
         </p:nvSpPr>
         <p:spPr>
           <a:xfrm>
-            <a:off x="822960" y="2286000"/>
-            <a:ext cx="2926080" cy="1371600"/>
+            <a:off x="1371600" y="2103120"/>
+            <a:ext cx="9418320" cy="914400"/>
           </a:xfrm>
           <a:prstGeom prst="roundRect">
             <a:avLst/>
@@ -5361,35 +5613,35 @@
           <a:bodyPr rtlCol="0" anchor="ctr" wrap="square"/>
           <a:lstStyle/>
           <a:p>
-            <a:pPr algn="ctr"/>
-            <a:r>
-              <a:rPr sz="3000" b="1">
+            <a:pPr algn="l"/>
+            <a:r>
+              <a:rPr sz="2600" b="1">
                 <a:solidFill>
                   <a:srgbClr val="1F3A5F"/>
                 </a:solidFill>
                 <a:latin typeface="Arial"/>
               </a:rPr>
-              <a:t>change</a:t>
-            </a:r>
-          </a:p>
-        </p:txBody>
-      </p:sp>
-      <p:sp>
-        <p:nvSpPr>
-          <p:cNvPr id="5" name="Right Arrow 4"/>
+              <a:t>1.  Roll the moving marble toward the target.</a:t>
+            </a:r>
+          </a:p>
+        </p:txBody>
+      </p:sp>
+      <p:sp>
+        <p:nvSpPr>
+          <p:cNvPr id="6" name="Rounded Rectangle 5"/>
           <p:cNvSpPr/>
           <p:nvPr/>
         </p:nvSpPr>
         <p:spPr>
           <a:xfrm>
-            <a:off x="3840480" y="2834640"/>
-            <a:ext cx="822960" cy="548640"/>
-          </a:xfrm>
-          <a:prstGeom prst="rightArrow">
+            <a:off x="1371600" y="3291839"/>
+            <a:ext cx="9418320" cy="914400"/>
+          </a:xfrm>
+          <a:prstGeom prst="roundRect">
             <a:avLst/>
           </a:prstGeom>
           <a:solidFill>
-            <a:srgbClr val="C05014"/>
+            <a:srgbClr val="E8EDF4"/>
           </a:solidFill>
           <a:ln>
             <a:noFill/>
@@ -5410,29 +5662,38 @@
           </a:fontRef>
         </p:style>
         <p:txBody>
-          <a:bodyPr rtlCol="0" anchor="ctr"/>
-          <a:lstStyle/>
-          <a:p>
-            <a:pPr algn="ctr"/>
-          </a:p>
-        </p:txBody>
-      </p:sp>
-      <p:sp>
-        <p:nvSpPr>
-          <p:cNvPr id="6" name="Rounded Rectangle 5"/>
+          <a:bodyPr rtlCol="0" anchor="ctr" wrap="square"/>
+          <a:lstStyle/>
+          <a:p>
+            <a:pPr algn="l"/>
+            <a:r>
+              <a:rPr sz="2600" b="1">
+                <a:solidFill>
+                  <a:srgbClr val="1F3A5F"/>
+                </a:solidFill>
+                <a:latin typeface="Arial"/>
+              </a:rPr>
+              <a:t>2.  Observe what the target does.</a:t>
+            </a:r>
+          </a:p>
+        </p:txBody>
+      </p:sp>
+      <p:sp>
+        <p:nvSpPr>
+          <p:cNvPr id="7" name="Rounded Rectangle 6"/>
           <p:cNvSpPr/>
           <p:nvPr/>
         </p:nvSpPr>
         <p:spPr>
           <a:xfrm>
-            <a:off x="4754880" y="2286000"/>
-            <a:ext cx="2926080" cy="1371600"/>
+            <a:off x="1371600" y="4480560"/>
+            <a:ext cx="9418320" cy="914400"/>
           </a:xfrm>
           <a:prstGeom prst="roundRect">
             <a:avLst/>
           </a:prstGeom>
           <a:solidFill>
-            <a:srgbClr val="2E6B3F"/>
+            <a:srgbClr val="E8EDF4"/>
           </a:solidFill>
           <a:ln>
             <a:noFill/>
@@ -5456,29 +5717,29 @@
           <a:bodyPr rtlCol="0" anchor="ctr" wrap="square"/>
           <a:lstStyle/>
           <a:p>
-            <a:pPr algn="ctr"/>
-            <a:r>
-              <a:rPr sz="2800" b="1">
-                <a:solidFill>
-                  <a:srgbClr val="FFFFFF"/>
-                </a:solidFill>
-                <a:latin typeface="Arial"/>
-              </a:rPr>
-              <a:t>evidence</a:t>
-            </a:r>
-          </a:p>
-        </p:txBody>
-      </p:sp>
-      <p:sp>
-        <p:nvSpPr>
-          <p:cNvPr id="7" name="TextBox 6"/>
+            <a:pPr algn="l"/>
+            <a:r>
+              <a:rPr sz="2600" b="1">
+                <a:solidFill>
+                  <a:srgbClr val="1F3A5F"/>
+                </a:solidFill>
+                <a:latin typeface="Arial"/>
+              </a:rPr>
+              <a:t>3.  Record what changed.</a:t>
+            </a:r>
+          </a:p>
+        </p:txBody>
+      </p:sp>
+      <p:sp>
+        <p:nvSpPr>
+          <p:cNvPr id="8" name="TextBox 7"/>
           <p:cNvSpPr txBox="1"/>
           <p:nvPr/>
         </p:nvSpPr>
         <p:spPr>
           <a:xfrm>
-            <a:off x="822960" y="4480560"/>
-            <a:ext cx="10515600" cy="822960"/>
+            <a:off x="11338560" y="6446520"/>
+            <a:ext cx="731520" cy="365760"/>
           </a:xfrm>
           <a:prstGeom prst="rect">
             <a:avLst/>
@@ -5491,41 +5752,6 @@
           </a:bodyPr>
           <a:lstStyle/>
           <a:p>
-            <a:pPr algn="ctr"/>
-            <a:r>
-              <a:rPr sz="2600" b="1">
-                <a:solidFill>
-                  <a:srgbClr val="1F3A5F"/>
-                </a:solidFill>
-                <a:latin typeface="Arial"/>
-              </a:rPr>
-              <a:t>The target's change is evidence the marble had energy.</a:t>
-            </a:r>
-          </a:p>
-        </p:txBody>
-      </p:sp>
-      <p:sp>
-        <p:nvSpPr>
-          <p:cNvPr id="8" name="TextBox 7"/>
-          <p:cNvSpPr txBox="1"/>
-          <p:nvPr/>
-        </p:nvSpPr>
-        <p:spPr>
-          <a:xfrm>
-            <a:off x="11338560" y="6446520"/>
-            <a:ext cx="731520" cy="365760"/>
-          </a:xfrm>
-          <a:prstGeom prst="rect">
-            <a:avLst/>
-          </a:prstGeom>
-          <a:noFill/>
-        </p:spPr>
-        <p:txBody>
-          <a:bodyPr wrap="square" anchor="t">
-            <a:spAutoFit/>
-          </a:bodyPr>
-          <a:lstStyle/>
-          <a:p>
             <a:pPr algn="r"/>
             <a:r>
               <a:rPr sz="1200" b="0">
@@ -5534,7 +5760,7 @@
                 </a:solidFill>
                 <a:latin typeface="Arial"/>
               </a:rPr>
-              <a:t>17</a:t>
+              <a:t>15</a:t>
             </a:r>
           </a:p>
         </p:txBody>
@@ -5630,21 +5856,56 @@
                 </a:solidFill>
                 <a:latin typeface="Arial"/>
               </a:rPr>
-              <a:t>Reader connection</a:t>
-            </a:r>
-          </a:p>
-        </p:txBody>
-      </p:sp>
-      <p:sp>
-        <p:nvSpPr>
-          <p:cNvPr id="4" name="Rounded Rectangle 3"/>
+              <a:t>Record your evidence</a:t>
+            </a:r>
+          </a:p>
+        </p:txBody>
+      </p:sp>
+      <p:sp>
+        <p:nvSpPr>
+          <p:cNvPr id="4" name="TextBox 3"/>
+          <p:cNvSpPr txBox="1"/>
+          <p:nvPr/>
+        </p:nvSpPr>
+        <p:spPr>
+          <a:xfrm>
+            <a:off x="502920" y="1170432"/>
+            <a:ext cx="11247120" cy="457200"/>
+          </a:xfrm>
+          <a:prstGeom prst="rect">
+            <a:avLst/>
+          </a:prstGeom>
+          <a:noFill/>
+        </p:spPr>
+        <p:txBody>
+          <a:bodyPr wrap="square" anchor="t">
+            <a:spAutoFit/>
+          </a:bodyPr>
+          <a:lstStyle/>
+          <a:p>
+            <a:pPr algn="l"/>
+            <a:r>
+              <a:rPr sz="1600" b="0">
+                <a:solidFill>
+                  <a:srgbClr val="555555"/>
+                </a:solidFill>
+                <a:latin typeface="Arial"/>
+              </a:rPr>
+              <a:t>Lab</a:t>
+            </a:r>
+          </a:p>
+        </p:txBody>
+      </p:sp>
+      <p:sp>
+        <p:nvSpPr>
+          <p:cNvPr id="5" name="Rounded Rectangle 4"/>
           <p:cNvSpPr/>
           <p:nvPr/>
         </p:nvSpPr>
         <p:spPr>
           <a:xfrm>
-            <a:off x="914400" y="2377440"/>
-            <a:ext cx="10332720" cy="1828800"/>
+            <a:off x="822960" y="2194560"/>
+            <a:ext cx="10515600" cy="2926080"/>
           </a:xfrm>
           <a:prstGeom prst="roundRect">
             <a:avLst/>
@@ -5675,28 +5936,19 @@
           <a:lstStyle/>
           <a:p>
             <a:pPr algn="ctr"/>
-            <a:r>
-              <a:rPr sz="3000" b="1">
-                <a:solidFill>
-                  <a:srgbClr val="1F3A5F"/>
-                </a:solidFill>
-                <a:latin typeface="Arial"/>
-              </a:rPr>
-              <a:t>All moving objects have energy of motion.</a:t>
-            </a:r>
-          </a:p>
-        </p:txBody>
-      </p:sp>
-      <p:sp>
-        <p:nvSpPr>
-          <p:cNvPr id="5" name="TextBox 4"/>
+          </a:p>
+        </p:txBody>
+      </p:sp>
+      <p:sp>
+        <p:nvSpPr>
+          <p:cNvPr id="6" name="TextBox 5"/>
           <p:cNvSpPr txBox="1"/>
           <p:nvPr/>
         </p:nvSpPr>
         <p:spPr>
           <a:xfrm>
-            <a:off x="914400" y="4572000"/>
-            <a:ext cx="10332720" cy="640080"/>
+            <a:off x="1371600" y="2468880"/>
+            <a:ext cx="9418320" cy="731520"/>
           </a:xfrm>
           <a:prstGeom prst="rect">
             <a:avLst/>
@@ -5709,29 +5961,29 @@
           </a:bodyPr>
           <a:lstStyle/>
           <a:p>
-            <a:pPr algn="ctr"/>
-            <a:r>
-              <a:rPr sz="2000" b="0">
-                <a:solidFill>
-                  <a:srgbClr val="555555"/>
-                </a:solidFill>
-                <a:latin typeface="Arial"/>
-              </a:rPr>
-              <a:t>— Student Reader, p. 9</a:t>
-            </a:r>
-          </a:p>
-        </p:txBody>
-      </p:sp>
-      <p:sp>
-        <p:nvSpPr>
-          <p:cNvPr id="6" name="TextBox 5"/>
+            <a:pPr algn="l"/>
+            <a:r>
+              <a:rPr sz="2400" b="0">
+                <a:solidFill>
+                  <a:srgbClr val="1F3A5F"/>
+                </a:solidFill>
+                <a:latin typeface="Arial"/>
+              </a:rPr>
+              <a:t>What moved before?</a:t>
+            </a:r>
+          </a:p>
+        </p:txBody>
+      </p:sp>
+      <p:sp>
+        <p:nvSpPr>
+          <p:cNvPr id="7" name="TextBox 6"/>
           <p:cNvSpPr txBox="1"/>
           <p:nvPr/>
         </p:nvSpPr>
         <p:spPr>
           <a:xfrm>
-            <a:off x="11338560" y="6446520"/>
-            <a:ext cx="731520" cy="365760"/>
+            <a:off x="1371600" y="3337560"/>
+            <a:ext cx="9418320" cy="731520"/>
           </a:xfrm>
           <a:prstGeom prst="rect">
             <a:avLst/>
@@ -5744,6 +5996,76 @@
           </a:bodyPr>
           <a:lstStyle/>
           <a:p>
+            <a:pPr algn="l"/>
+            <a:r>
+              <a:rPr sz="2400" b="0">
+                <a:solidFill>
+                  <a:srgbClr val="1F3A5F"/>
+                </a:solidFill>
+                <a:latin typeface="Arial"/>
+              </a:rPr>
+              <a:t>What changed after contact?</a:t>
+            </a:r>
+          </a:p>
+        </p:txBody>
+      </p:sp>
+      <p:sp>
+        <p:nvSpPr>
+          <p:cNvPr id="8" name="TextBox 7"/>
+          <p:cNvSpPr txBox="1"/>
+          <p:nvPr/>
+        </p:nvSpPr>
+        <p:spPr>
+          <a:xfrm>
+            <a:off x="1371600" y="4206240"/>
+            <a:ext cx="9418320" cy="731520"/>
+          </a:xfrm>
+          <a:prstGeom prst="rect">
+            <a:avLst/>
+          </a:prstGeom>
+          <a:noFill/>
+        </p:spPr>
+        <p:txBody>
+          <a:bodyPr wrap="square" anchor="t">
+            <a:spAutoFit/>
+          </a:bodyPr>
+          <a:lstStyle/>
+          <a:p>
+            <a:pPr algn="l"/>
+            <a:r>
+              <a:rPr sz="2400" b="0">
+                <a:solidFill>
+                  <a:srgbClr val="1F3A5F"/>
+                </a:solidFill>
+                <a:latin typeface="Arial"/>
+              </a:rPr>
+              <a:t>How did the target change?</a:t>
+            </a:r>
+          </a:p>
+        </p:txBody>
+      </p:sp>
+      <p:sp>
+        <p:nvSpPr>
+          <p:cNvPr id="9" name="TextBox 8"/>
+          <p:cNvSpPr txBox="1"/>
+          <p:nvPr/>
+        </p:nvSpPr>
+        <p:spPr>
+          <a:xfrm>
+            <a:off x="11338560" y="6446520"/>
+            <a:ext cx="731520" cy="365760"/>
+          </a:xfrm>
+          <a:prstGeom prst="rect">
+            <a:avLst/>
+          </a:prstGeom>
+          <a:noFill/>
+        </p:spPr>
+        <p:txBody>
+          <a:bodyPr wrap="square" anchor="t">
+            <a:spAutoFit/>
+          </a:bodyPr>
+          <a:lstStyle/>
+          <a:p>
             <a:pPr algn="r"/>
             <a:r>
               <a:rPr sz="1200" b="0">
@@ -5752,7 +6074,7 @@
                 </a:solidFill>
                 <a:latin typeface="Arial"/>
               </a:rPr>
-              <a:t>18</a:t>
+              <a:t>16</a:t>
             </a:r>
           </a:p>
         </p:txBody>
@@ -5848,7 +6170,7 @@
                 </a:solidFill>
                 <a:latin typeface="Arial"/>
               </a:rPr>
-              <a:t>Observation vs inference</a:t>
+              <a:t>Debrief</a:t>
             </a:r>
           </a:p>
         </p:txBody>
@@ -5861,8 +6183,8 @@
         </p:nvSpPr>
         <p:spPr>
           <a:xfrm>
-            <a:off x="822960" y="2194560"/>
-            <a:ext cx="5029200" cy="2377440"/>
+            <a:off x="822960" y="2286000"/>
+            <a:ext cx="2926080" cy="1371600"/>
           </a:xfrm>
           <a:prstGeom prst="roundRect">
             <a:avLst/>
@@ -5894,28 +6216,70 @@
           <a:p>
             <a:pPr algn="ctr"/>
             <a:r>
-              <a:rPr sz="2400" b="1">
+              <a:rPr sz="3000" b="1">
                 <a:solidFill>
                   <a:srgbClr val="1F3A5F"/>
                 </a:solidFill>
                 <a:latin typeface="Arial"/>
               </a:rPr>
-              <a:t>OBSERVATION
-I saw the target move.</a:t>
-            </a:r>
-          </a:p>
-        </p:txBody>
-      </p:sp>
-      <p:sp>
-        <p:nvSpPr>
-          <p:cNvPr id="5" name="Rounded Rectangle 4"/>
+              <a:t>change</a:t>
+            </a:r>
+          </a:p>
+        </p:txBody>
+      </p:sp>
+      <p:sp>
+        <p:nvSpPr>
+          <p:cNvPr id="5" name="Right Arrow 4"/>
           <p:cNvSpPr/>
           <p:nvPr/>
         </p:nvSpPr>
         <p:spPr>
           <a:xfrm>
-            <a:off x="6309360" y="2194560"/>
-            <a:ext cx="5029200" cy="2377440"/>
+            <a:off x="3840480" y="2834640"/>
+            <a:ext cx="822960" cy="548640"/>
+          </a:xfrm>
+          <a:prstGeom prst="rightArrow">
+            <a:avLst/>
+          </a:prstGeom>
+          <a:solidFill>
+            <a:srgbClr val="C05014"/>
+          </a:solidFill>
+          <a:ln>
+            <a:noFill/>
+          </a:ln>
+        </p:spPr>
+        <p:style>
+          <a:lnRef idx="1">
+            <a:schemeClr val="accent1"/>
+          </a:lnRef>
+          <a:fillRef idx="3">
+            <a:schemeClr val="accent1"/>
+          </a:fillRef>
+          <a:effectRef idx="2">
+            <a:schemeClr val="accent1"/>
+          </a:effectRef>
+          <a:fontRef idx="minor">
+            <a:schemeClr val="lt1"/>
+          </a:fontRef>
+        </p:style>
+        <p:txBody>
+          <a:bodyPr rtlCol="0" anchor="ctr"/>
+          <a:lstStyle/>
+          <a:p>
+            <a:pPr algn="ctr"/>
+          </a:p>
+        </p:txBody>
+      </p:sp>
+      <p:sp>
+        <p:nvSpPr>
+          <p:cNvPr id="6" name="Rounded Rectangle 5"/>
+          <p:cNvSpPr/>
+          <p:nvPr/>
+        </p:nvSpPr>
+        <p:spPr>
+          <a:xfrm>
+            <a:off x="4754880" y="2286000"/>
+            <a:ext cx="2926080" cy="1371600"/>
           </a:xfrm>
           <a:prstGeom prst="roundRect">
             <a:avLst/>
@@ -5947,28 +6311,27 @@
           <a:p>
             <a:pPr algn="ctr"/>
             <a:r>
-              <a:rPr sz="2200" b="1">
+              <a:rPr sz="2800" b="1">
                 <a:solidFill>
                   <a:srgbClr val="FFFFFF"/>
                 </a:solidFill>
                 <a:latin typeface="Arial"/>
               </a:rPr>
-              <a:t>INFERENCE
-I think the marble had energy.</a:t>
-            </a:r>
-          </a:p>
-        </p:txBody>
-      </p:sp>
-      <p:sp>
-        <p:nvSpPr>
-          <p:cNvPr id="6" name="TextBox 5"/>
+              <a:t>evidence</a:t>
+            </a:r>
+          </a:p>
+        </p:txBody>
+      </p:sp>
+      <p:sp>
+        <p:nvSpPr>
+          <p:cNvPr id="7" name="TextBox 6"/>
           <p:cNvSpPr txBox="1"/>
           <p:nvPr/>
         </p:nvSpPr>
         <p:spPr>
           <a:xfrm>
-            <a:off x="11338560" y="6446520"/>
-            <a:ext cx="731520" cy="365760"/>
+            <a:off x="822960" y="4480560"/>
+            <a:ext cx="10515600" cy="822960"/>
           </a:xfrm>
           <a:prstGeom prst="rect">
             <a:avLst/>
@@ -5981,6 +6344,41 @@
           </a:bodyPr>
           <a:lstStyle/>
           <a:p>
+            <a:pPr algn="ctr"/>
+            <a:r>
+              <a:rPr sz="2600" b="1">
+                <a:solidFill>
+                  <a:srgbClr val="1F3A5F"/>
+                </a:solidFill>
+                <a:latin typeface="Arial"/>
+              </a:rPr>
+              <a:t>The target's change is evidence the marble had energy.</a:t>
+            </a:r>
+          </a:p>
+        </p:txBody>
+      </p:sp>
+      <p:sp>
+        <p:nvSpPr>
+          <p:cNvPr id="8" name="TextBox 7"/>
+          <p:cNvSpPr txBox="1"/>
+          <p:nvPr/>
+        </p:nvSpPr>
+        <p:spPr>
+          <a:xfrm>
+            <a:off x="11338560" y="6446520"/>
+            <a:ext cx="731520" cy="365760"/>
+          </a:xfrm>
+          <a:prstGeom prst="rect">
+            <a:avLst/>
+          </a:prstGeom>
+          <a:noFill/>
+        </p:spPr>
+        <p:txBody>
+          <a:bodyPr wrap="square" anchor="t">
+            <a:spAutoFit/>
+          </a:bodyPr>
+          <a:lstStyle/>
+          <a:p>
             <a:pPr algn="r"/>
             <a:r>
               <a:rPr sz="1200" b="0">
@@ -5989,7 +6387,7 @@
                 </a:solidFill>
                 <a:latin typeface="Arial"/>
               </a:rPr>
-              <a:t>19</a:t>
+              <a:t>17</a:t>
             </a:r>
           </a:p>
         </p:txBody>
@@ -6400,7 +6798,7 @@
                 </a:solidFill>
                 <a:latin typeface="Arial"/>
               </a:rPr>
-              <a:t>Moving objects cause changes</a:t>
+              <a:t>Reader connection</a:t>
             </a:r>
           </a:p>
         </p:txBody>
@@ -6413,14 +6811,14 @@
         </p:nvSpPr>
         <p:spPr>
           <a:xfrm>
-            <a:off x="822960" y="2743200"/>
-            <a:ext cx="3383280" cy="1463040"/>
+            <a:off x="914400" y="2377440"/>
+            <a:ext cx="10332720" cy="1828800"/>
           </a:xfrm>
           <a:prstGeom prst="roundRect">
             <a:avLst/>
           </a:prstGeom>
           <a:solidFill>
-            <a:srgbClr val="1F3A5F"/>
+            <a:srgbClr val="E8EDF4"/>
           </a:solidFill>
           <a:ln>
             <a:noFill/>
@@ -6446,131 +6844,27 @@
           <a:p>
             <a:pPr algn="ctr"/>
             <a:r>
-              <a:rPr sz="2200" b="1">
-                <a:solidFill>
-                  <a:srgbClr val="FFFFFF"/>
-                </a:solidFill>
-                <a:latin typeface="Arial"/>
-              </a:rPr>
-              <a:t>basketball → net</a:t>
-            </a:r>
-          </a:p>
-        </p:txBody>
-      </p:sp>
-      <p:sp>
-        <p:nvSpPr>
-          <p:cNvPr id="5" name="Rounded Rectangle 4"/>
-          <p:cNvSpPr/>
-          <p:nvPr/>
-        </p:nvSpPr>
-        <p:spPr>
-          <a:xfrm>
-            <a:off x="4480560" y="2743200"/>
-            <a:ext cx="3383280" cy="1463040"/>
-          </a:xfrm>
-          <a:prstGeom prst="roundRect">
-            <a:avLst/>
-          </a:prstGeom>
-          <a:solidFill>
-            <a:srgbClr val="1F3A5F"/>
-          </a:solidFill>
-          <a:ln>
-            <a:noFill/>
-          </a:ln>
-        </p:spPr>
-        <p:style>
-          <a:lnRef idx="1">
-            <a:schemeClr val="accent1"/>
-          </a:lnRef>
-          <a:fillRef idx="3">
-            <a:schemeClr val="accent1"/>
-          </a:fillRef>
-          <a:effectRef idx="2">
-            <a:schemeClr val="accent1"/>
-          </a:effectRef>
-          <a:fontRef idx="minor">
-            <a:schemeClr val="lt1"/>
-          </a:fontRef>
-        </p:style>
-        <p:txBody>
-          <a:bodyPr rtlCol="0" anchor="ctr" wrap="square"/>
-          <a:lstStyle/>
-          <a:p>
-            <a:pPr algn="ctr"/>
-            <a:r>
-              <a:rPr sz="2200" b="1">
-                <a:solidFill>
-                  <a:srgbClr val="FFFFFF"/>
-                </a:solidFill>
-                <a:latin typeface="Arial"/>
-              </a:rPr>
-              <a:t>raindrops → puddle</a:t>
-            </a:r>
-          </a:p>
-        </p:txBody>
-      </p:sp>
-      <p:sp>
-        <p:nvSpPr>
-          <p:cNvPr id="6" name="Rounded Rectangle 5"/>
-          <p:cNvSpPr/>
-          <p:nvPr/>
-        </p:nvSpPr>
-        <p:spPr>
-          <a:xfrm>
-            <a:off x="8138160" y="2743200"/>
-            <a:ext cx="3383280" cy="1463040"/>
-          </a:xfrm>
-          <a:prstGeom prst="roundRect">
-            <a:avLst/>
-          </a:prstGeom>
-          <a:solidFill>
-            <a:srgbClr val="1F3A5F"/>
-          </a:solidFill>
-          <a:ln>
-            <a:noFill/>
-          </a:ln>
-        </p:spPr>
-        <p:style>
-          <a:lnRef idx="1">
-            <a:schemeClr val="accent1"/>
-          </a:lnRef>
-          <a:fillRef idx="3">
-            <a:schemeClr val="accent1"/>
-          </a:fillRef>
-          <a:effectRef idx="2">
-            <a:schemeClr val="accent1"/>
-          </a:effectRef>
-          <a:fontRef idx="minor">
-            <a:schemeClr val="lt1"/>
-          </a:fontRef>
-        </p:style>
-        <p:txBody>
-          <a:bodyPr rtlCol="0" anchor="ctr" wrap="square"/>
-          <a:lstStyle/>
-          <a:p>
-            <a:pPr algn="ctr"/>
-            <a:r>
-              <a:rPr sz="2200" b="1">
-                <a:solidFill>
-                  <a:srgbClr val="FFFFFF"/>
-                </a:solidFill>
-                <a:latin typeface="Arial"/>
-              </a:rPr>
-              <a:t>wind → turbine</a:t>
-            </a:r>
-          </a:p>
-        </p:txBody>
-      </p:sp>
-      <p:sp>
-        <p:nvSpPr>
-          <p:cNvPr id="7" name="TextBox 6"/>
+              <a:rPr sz="3000" b="1">
+                <a:solidFill>
+                  <a:srgbClr val="1F3A5F"/>
+                </a:solidFill>
+                <a:latin typeface="Arial"/>
+              </a:rPr>
+              <a:t>All moving objects have energy of motion.</a:t>
+            </a:r>
+          </a:p>
+        </p:txBody>
+      </p:sp>
+      <p:sp>
+        <p:nvSpPr>
+          <p:cNvPr id="5" name="TextBox 4"/>
           <p:cNvSpPr txBox="1"/>
           <p:nvPr/>
         </p:nvSpPr>
         <p:spPr>
           <a:xfrm>
-            <a:off x="11338560" y="6446520"/>
-            <a:ext cx="731520" cy="365760"/>
+            <a:off x="914400" y="4572000"/>
+            <a:ext cx="10332720" cy="640080"/>
           </a:xfrm>
           <a:prstGeom prst="rect">
             <a:avLst/>
@@ -6583,6 +6877,41 @@
           </a:bodyPr>
           <a:lstStyle/>
           <a:p>
+            <a:pPr algn="ctr"/>
+            <a:r>
+              <a:rPr sz="2000" b="0">
+                <a:solidFill>
+                  <a:srgbClr val="555555"/>
+                </a:solidFill>
+                <a:latin typeface="Arial"/>
+              </a:rPr>
+              <a:t>— Student Reader, p. 9</a:t>
+            </a:r>
+          </a:p>
+        </p:txBody>
+      </p:sp>
+      <p:sp>
+        <p:nvSpPr>
+          <p:cNvPr id="6" name="TextBox 5"/>
+          <p:cNvSpPr txBox="1"/>
+          <p:nvPr/>
+        </p:nvSpPr>
+        <p:spPr>
+          <a:xfrm>
+            <a:off x="11338560" y="6446520"/>
+            <a:ext cx="731520" cy="365760"/>
+          </a:xfrm>
+          <a:prstGeom prst="rect">
+            <a:avLst/>
+          </a:prstGeom>
+          <a:noFill/>
+        </p:spPr>
+        <p:txBody>
+          <a:bodyPr wrap="square" anchor="t">
+            <a:spAutoFit/>
+          </a:bodyPr>
+          <a:lstStyle/>
+          <a:p>
             <a:pPr algn="r"/>
             <a:r>
               <a:rPr sz="1200" b="0">
@@ -6591,7 +6920,7 @@
                 </a:solidFill>
                 <a:latin typeface="Arial"/>
               </a:rPr>
-              <a:t>20</a:t>
+              <a:t>18</a:t>
             </a:r>
           </a:p>
         </p:txBody>
@@ -6687,7 +7016,7 @@
                 </a:solidFill>
                 <a:latin typeface="Arial"/>
               </a:rPr>
-              <a:t>Non-example</a:t>
+              <a:t>Observation vs inference</a:t>
             </a:r>
           </a:p>
         </p:txBody>
@@ -6700,14 +7029,14 @@
         </p:nvSpPr>
         <p:spPr>
           <a:xfrm>
-            <a:off x="914400" y="2286000"/>
-            <a:ext cx="4572000" cy="2011680"/>
+            <a:off x="822960" y="2194560"/>
+            <a:ext cx="5029200" cy="2377440"/>
           </a:xfrm>
           <a:prstGeom prst="roundRect">
             <a:avLst/>
           </a:prstGeom>
           <a:solidFill>
-            <a:srgbClr val="555555"/>
+            <a:srgbClr val="E8EDF4"/>
           </a:solidFill>
           <a:ln>
             <a:noFill/>
@@ -6733,28 +7062,81 @@
           <a:p>
             <a:pPr algn="ctr"/>
             <a:r>
-              <a:rPr sz="2800" b="1">
+              <a:rPr sz="2400" b="1">
+                <a:solidFill>
+                  <a:srgbClr val="1F3A5F"/>
+                </a:solidFill>
+                <a:latin typeface="Arial"/>
+              </a:rPr>
+              <a:t>OBSERVATION
+I saw the target move.</a:t>
+            </a:r>
+          </a:p>
+        </p:txBody>
+      </p:sp>
+      <p:sp>
+        <p:nvSpPr>
+          <p:cNvPr id="5" name="Rounded Rectangle 4"/>
+          <p:cNvSpPr/>
+          <p:nvPr/>
+        </p:nvSpPr>
+        <p:spPr>
+          <a:xfrm>
+            <a:off x="6309360" y="2194560"/>
+            <a:ext cx="5029200" cy="2377440"/>
+          </a:xfrm>
+          <a:prstGeom prst="roundRect">
+            <a:avLst/>
+          </a:prstGeom>
+          <a:solidFill>
+            <a:srgbClr val="2E6B3F"/>
+          </a:solidFill>
+          <a:ln>
+            <a:noFill/>
+          </a:ln>
+        </p:spPr>
+        <p:style>
+          <a:lnRef idx="1">
+            <a:schemeClr val="accent1"/>
+          </a:lnRef>
+          <a:fillRef idx="3">
+            <a:schemeClr val="accent1"/>
+          </a:fillRef>
+          <a:effectRef idx="2">
+            <a:schemeClr val="accent1"/>
+          </a:effectRef>
+          <a:fontRef idx="minor">
+            <a:schemeClr val="lt1"/>
+          </a:fontRef>
+        </p:style>
+        <p:txBody>
+          <a:bodyPr rtlCol="0" anchor="ctr" wrap="square"/>
+          <a:lstStyle/>
+          <a:p>
+            <a:pPr algn="ctr"/>
+            <a:r>
+              <a:rPr sz="2200" b="1">
                 <a:solidFill>
                   <a:srgbClr val="FFFFFF"/>
                 </a:solidFill>
                 <a:latin typeface="Arial"/>
               </a:rPr>
-              <a:t>book sitting
-on a table</a:t>
-            </a:r>
-          </a:p>
-        </p:txBody>
-      </p:sp>
-      <p:sp>
-        <p:nvSpPr>
-          <p:cNvPr id="5" name="TextBox 4"/>
+              <a:t>INFERENCE
+I think the marble had energy.</a:t>
+            </a:r>
+          </a:p>
+        </p:txBody>
+      </p:sp>
+      <p:sp>
+        <p:nvSpPr>
+          <p:cNvPr id="6" name="TextBox 5"/>
           <p:cNvSpPr txBox="1"/>
           <p:nvPr/>
         </p:nvSpPr>
         <p:spPr>
           <a:xfrm>
-            <a:off x="914400" y="4663440"/>
-            <a:ext cx="10332720" cy="731520"/>
+            <a:off x="11338560" y="6446520"/>
+            <a:ext cx="731520" cy="365760"/>
           </a:xfrm>
           <a:prstGeom prst="rect">
             <a:avLst/>
@@ -6767,41 +7149,6 @@
           </a:bodyPr>
           <a:lstStyle/>
           <a:p>
-            <a:pPr algn="ctr"/>
-            <a:r>
-              <a:rPr sz="2600" b="1">
-                <a:solidFill>
-                  <a:srgbClr val="1F3A5F"/>
-                </a:solidFill>
-                <a:latin typeface="Arial"/>
-              </a:rPr>
-              <a:t>Not moving → no change → no energy of motion.</a:t>
-            </a:r>
-          </a:p>
-        </p:txBody>
-      </p:sp>
-      <p:sp>
-        <p:nvSpPr>
-          <p:cNvPr id="6" name="TextBox 5"/>
-          <p:cNvSpPr txBox="1"/>
-          <p:nvPr/>
-        </p:nvSpPr>
-        <p:spPr>
-          <a:xfrm>
-            <a:off x="11338560" y="6446520"/>
-            <a:ext cx="731520" cy="365760"/>
-          </a:xfrm>
-          <a:prstGeom prst="rect">
-            <a:avLst/>
-          </a:prstGeom>
-          <a:noFill/>
-        </p:spPr>
-        <p:txBody>
-          <a:bodyPr wrap="square" anchor="t">
-            <a:spAutoFit/>
-          </a:bodyPr>
-          <a:lstStyle/>
-          <a:p>
             <a:pPr algn="r"/>
             <a:r>
               <a:rPr sz="1200" b="0">
@@ -6810,7 +7157,7 @@
                 </a:solidFill>
                 <a:latin typeface="Arial"/>
               </a:rPr>
-              <a:t>21</a:t>
+              <a:t>19</a:t>
             </a:r>
           </a:p>
         </p:txBody>
@@ -6906,7 +7253,7 @@
                 </a:solidFill>
                 <a:latin typeface="Arial"/>
               </a:rPr>
-              <a:t>Bring it together</a:t>
+              <a:t>Moving objects cause changes</a:t>
             </a:r>
           </a:p>
         </p:txBody>
@@ -6919,14 +7266,14 @@
         </p:nvSpPr>
         <p:spPr>
           <a:xfrm>
-            <a:off x="822960" y="2286000"/>
-            <a:ext cx="2926080" cy="1371600"/>
+            <a:off x="822960" y="2743200"/>
+            <a:ext cx="3383280" cy="1463040"/>
           </a:xfrm>
           <a:prstGeom prst="roundRect">
             <a:avLst/>
           </a:prstGeom>
           <a:solidFill>
-            <a:srgbClr val="C05014"/>
+            <a:srgbClr val="1F3A5F"/>
           </a:solidFill>
           <a:ln>
             <a:noFill/>
@@ -6958,27 +7305,27 @@
                 </a:solidFill>
                 <a:latin typeface="Arial"/>
               </a:rPr>
-              <a:t>MOVING OBJECT</a:t>
-            </a:r>
-          </a:p>
-        </p:txBody>
-      </p:sp>
-      <p:sp>
-        <p:nvSpPr>
-          <p:cNvPr id="5" name="Right Arrow 4"/>
+              <a:t>basketball → net</a:t>
+            </a:r>
+          </a:p>
+        </p:txBody>
+      </p:sp>
+      <p:sp>
+        <p:nvSpPr>
+          <p:cNvPr id="5" name="Rounded Rectangle 4"/>
           <p:cNvSpPr/>
           <p:nvPr/>
         </p:nvSpPr>
         <p:spPr>
           <a:xfrm>
-            <a:off x="3840480" y="2834640"/>
-            <a:ext cx="822960" cy="548640"/>
-          </a:xfrm>
-          <a:prstGeom prst="rightArrow">
+            <a:off x="4480560" y="2743200"/>
+            <a:ext cx="3383280" cy="1463040"/>
+          </a:xfrm>
+          <a:prstGeom prst="roundRect">
             <a:avLst/>
           </a:prstGeom>
           <a:solidFill>
-            <a:srgbClr val="C05014"/>
+            <a:srgbClr val="1F3A5F"/>
           </a:solidFill>
           <a:ln>
             <a:noFill/>
@@ -6999,10 +7346,19 @@
           </a:fontRef>
         </p:style>
         <p:txBody>
-          <a:bodyPr rtlCol="0" anchor="ctr"/>
+          <a:bodyPr rtlCol="0" anchor="ctr" wrap="square"/>
           <a:lstStyle/>
           <a:p>
             <a:pPr algn="ctr"/>
+            <a:r>
+              <a:rPr sz="2200" b="1">
+                <a:solidFill>
+                  <a:srgbClr val="FFFFFF"/>
+                </a:solidFill>
+                <a:latin typeface="Arial"/>
+              </a:rPr>
+              <a:t>raindrops → puddle</a:t>
+            </a:r>
           </a:p>
         </p:txBody>
       </p:sp>
@@ -7014,14 +7370,14 @@
         </p:nvSpPr>
         <p:spPr>
           <a:xfrm>
-            <a:off x="4754880" y="2286000"/>
-            <a:ext cx="2743200" cy="1371600"/>
+            <a:off x="8138160" y="2743200"/>
+            <a:ext cx="3383280" cy="1463040"/>
           </a:xfrm>
           <a:prstGeom prst="roundRect">
             <a:avLst/>
           </a:prstGeom>
           <a:solidFill>
-            <a:srgbClr val="E8EDF4"/>
+            <a:srgbClr val="1F3A5F"/>
           </a:solidFill>
           <a:ln>
             <a:noFill/>
@@ -7047,122 +7403,27 @@
           <a:p>
             <a:pPr algn="ctr"/>
             <a:r>
-              <a:rPr sz="2600" b="1">
-                <a:solidFill>
-                  <a:srgbClr val="1F3A5F"/>
-                </a:solidFill>
-                <a:latin typeface="Arial"/>
-              </a:rPr>
-              <a:t>CHANGE</a:t>
-            </a:r>
-          </a:p>
-        </p:txBody>
-      </p:sp>
-      <p:sp>
-        <p:nvSpPr>
-          <p:cNvPr id="7" name="Right Arrow 6"/>
-          <p:cNvSpPr/>
-          <p:nvPr/>
-        </p:nvSpPr>
-        <p:spPr>
-          <a:xfrm>
-            <a:off x="7589520" y="2834640"/>
-            <a:ext cx="822960" cy="548640"/>
-          </a:xfrm>
-          <a:prstGeom prst="rightArrow">
-            <a:avLst/>
-          </a:prstGeom>
-          <a:solidFill>
-            <a:srgbClr val="C05014"/>
-          </a:solidFill>
-          <a:ln>
-            <a:noFill/>
-          </a:ln>
-        </p:spPr>
-        <p:style>
-          <a:lnRef idx="1">
-            <a:schemeClr val="accent1"/>
-          </a:lnRef>
-          <a:fillRef idx="3">
-            <a:schemeClr val="accent1"/>
-          </a:fillRef>
-          <a:effectRef idx="2">
-            <a:schemeClr val="accent1"/>
-          </a:effectRef>
-          <a:fontRef idx="minor">
-            <a:schemeClr val="lt1"/>
-          </a:fontRef>
-        </p:style>
-        <p:txBody>
-          <a:bodyPr rtlCol="0" anchor="ctr"/>
-          <a:lstStyle/>
-          <a:p>
-            <a:pPr algn="ctr"/>
-          </a:p>
-        </p:txBody>
-      </p:sp>
-      <p:sp>
-        <p:nvSpPr>
-          <p:cNvPr id="8" name="Rounded Rectangle 7"/>
-          <p:cNvSpPr/>
-          <p:nvPr/>
-        </p:nvSpPr>
-        <p:spPr>
-          <a:xfrm>
-            <a:off x="8503920" y="2286000"/>
-            <a:ext cx="2743200" cy="1371600"/>
-          </a:xfrm>
-          <a:prstGeom prst="roundRect">
-            <a:avLst/>
-          </a:prstGeom>
-          <a:solidFill>
-            <a:srgbClr val="2E6B3F"/>
-          </a:solidFill>
-          <a:ln>
-            <a:noFill/>
-          </a:ln>
-        </p:spPr>
-        <p:style>
-          <a:lnRef idx="1">
-            <a:schemeClr val="accent1"/>
-          </a:lnRef>
-          <a:fillRef idx="3">
-            <a:schemeClr val="accent1"/>
-          </a:fillRef>
-          <a:effectRef idx="2">
-            <a:schemeClr val="accent1"/>
-          </a:effectRef>
-          <a:fontRef idx="minor">
-            <a:schemeClr val="lt1"/>
-          </a:fontRef>
-        </p:style>
-        <p:txBody>
-          <a:bodyPr rtlCol="0" anchor="ctr" wrap="square"/>
-          <a:lstStyle/>
-          <a:p>
-            <a:pPr algn="ctr"/>
-            <a:r>
-              <a:rPr sz="2400" b="1">
+              <a:rPr sz="2200" b="1">
                 <a:solidFill>
                   <a:srgbClr val="FFFFFF"/>
                 </a:solidFill>
                 <a:latin typeface="Arial"/>
               </a:rPr>
-              <a:t>EVIDENCE</a:t>
-            </a:r>
-          </a:p>
-        </p:txBody>
-      </p:sp>
-      <p:sp>
-        <p:nvSpPr>
-          <p:cNvPr id="9" name="TextBox 8"/>
+              <a:t>wind → turbine</a:t>
+            </a:r>
+          </a:p>
+        </p:txBody>
+      </p:sp>
+      <p:sp>
+        <p:nvSpPr>
+          <p:cNvPr id="7" name="TextBox 6"/>
           <p:cNvSpPr txBox="1"/>
           <p:nvPr/>
         </p:nvSpPr>
         <p:spPr>
           <a:xfrm>
-            <a:off x="822960" y="4480560"/>
-            <a:ext cx="10515600" cy="822960"/>
+            <a:off x="11338560" y="6446520"/>
+            <a:ext cx="731520" cy="365760"/>
           </a:xfrm>
           <a:prstGeom prst="rect">
             <a:avLst/>
@@ -7175,41 +7436,6 @@
           </a:bodyPr>
           <a:lstStyle/>
           <a:p>
-            <a:pPr algn="ctr"/>
-            <a:r>
-              <a:rPr sz="2400" b="1">
-                <a:solidFill>
-                  <a:srgbClr val="1F3A5F"/>
-                </a:solidFill>
-                <a:latin typeface="Arial"/>
-              </a:rPr>
-              <a:t>Name one moving object and the change it caused.</a:t>
-            </a:r>
-          </a:p>
-        </p:txBody>
-      </p:sp>
-      <p:sp>
-        <p:nvSpPr>
-          <p:cNvPr id="10" name="TextBox 9"/>
-          <p:cNvSpPr txBox="1"/>
-          <p:nvPr/>
-        </p:nvSpPr>
-        <p:spPr>
-          <a:xfrm>
-            <a:off x="11338560" y="6446520"/>
-            <a:ext cx="731520" cy="365760"/>
-          </a:xfrm>
-          <a:prstGeom prst="rect">
-            <a:avLst/>
-          </a:prstGeom>
-          <a:noFill/>
-        </p:spPr>
-        <p:txBody>
-          <a:bodyPr wrap="square" anchor="t">
-            <a:spAutoFit/>
-          </a:bodyPr>
-          <a:lstStyle/>
-          <a:p>
             <a:pPr algn="r"/>
             <a:r>
               <a:rPr sz="1200" b="0">
@@ -7218,7 +7444,7 @@
                 </a:solidFill>
                 <a:latin typeface="Arial"/>
               </a:rPr>
-              <a:t>22</a:t>
+              <a:t>20</a:t>
             </a:r>
           </a:p>
         </p:txBody>
@@ -7293,7 +7519,7 @@
         <p:spPr>
           <a:xfrm>
             <a:off x="457200" y="146304"/>
-            <a:ext cx="10058400" cy="777240"/>
+            <a:ext cx="11247120" cy="777240"/>
           </a:xfrm>
           <a:prstGeom prst="rect">
             <a:avLst/>
@@ -7308,13 +7534,13 @@
           <a:p>
             <a:pPr algn="l"/>
             <a:r>
-              <a:rPr sz="3400" b="1" i="0">
+              <a:rPr sz="3400" b="1">
                 <a:solidFill>
                   <a:srgbClr val="FFFFFF"/>
                 </a:solidFill>
                 <a:latin typeface="Arial"/>
               </a:rPr>
-              <a:t>Notebook — Motion</a:t>
+              <a:t>Non-example</a:t>
             </a:r>
           </a:p>
         </p:txBody>
@@ -7327,14 +7553,14 @@
         </p:nvSpPr>
         <p:spPr>
           <a:xfrm>
-            <a:off x="9692640" y="256032"/>
-            <a:ext cx="2103120" cy="548640"/>
+            <a:off x="914400" y="2286000"/>
+            <a:ext cx="4572000" cy="2011680"/>
           </a:xfrm>
           <a:prstGeom prst="roundRect">
             <a:avLst/>
           </a:prstGeom>
           <a:solidFill>
-            <a:srgbClr val="C05014"/>
+            <a:srgbClr val="555555"/>
           </a:solidFill>
           <a:ln>
             <a:noFill/>
@@ -7360,70 +7586,28 @@
           <a:p>
             <a:pPr algn="ctr"/>
             <a:r>
-              <a:rPr sz="1800" b="1">
+              <a:rPr sz="2800" b="1">
                 <a:solidFill>
                   <a:srgbClr val="FFFFFF"/>
                 </a:solidFill>
                 <a:latin typeface="Arial"/>
               </a:rPr>
-              <a:t>NOTEBOOK</a:t>
-            </a:r>
-          </a:p>
-        </p:txBody>
-      </p:sp>
-      <p:sp>
-        <p:nvSpPr>
-          <p:cNvPr id="5" name="Rounded Rectangle 4"/>
-          <p:cNvSpPr/>
-          <p:nvPr/>
-        </p:nvSpPr>
-        <p:spPr>
-          <a:xfrm>
-            <a:off x="1097280" y="1737360"/>
-            <a:ext cx="9966960" cy="1234440"/>
-          </a:xfrm>
-          <a:prstGeom prst="roundRect">
-            <a:avLst/>
-          </a:prstGeom>
-          <a:solidFill>
-            <a:srgbClr val="E8EDF4"/>
-          </a:solidFill>
-          <a:ln>
-            <a:noFill/>
-          </a:ln>
-        </p:spPr>
-        <p:style>
-          <a:lnRef idx="1">
-            <a:schemeClr val="accent1"/>
-          </a:lnRef>
-          <a:fillRef idx="3">
-            <a:schemeClr val="accent1"/>
-          </a:fillRef>
-          <a:effectRef idx="2">
-            <a:schemeClr val="accent1"/>
-          </a:effectRef>
-          <a:fontRef idx="minor">
-            <a:schemeClr val="lt1"/>
-          </a:fontRef>
-        </p:style>
-        <p:txBody>
-          <a:bodyPr rtlCol="0" anchor="ctr" wrap="square"/>
-          <a:lstStyle/>
-          <a:p>
-            <a:pPr algn="ctr"/>
-          </a:p>
-        </p:txBody>
-      </p:sp>
-      <p:sp>
-        <p:nvSpPr>
-          <p:cNvPr id="6" name="TextBox 5"/>
+              <a:t>book sitting
+on a table</a:t>
+            </a:r>
+          </a:p>
+        </p:txBody>
+      </p:sp>
+      <p:sp>
+        <p:nvSpPr>
+          <p:cNvPr id="5" name="TextBox 4"/>
           <p:cNvSpPr txBox="1"/>
           <p:nvPr/>
         </p:nvSpPr>
         <p:spPr>
           <a:xfrm>
-            <a:off x="1371600" y="1828800"/>
-            <a:ext cx="9418320" cy="457200"/>
+            <a:off x="914400" y="4663440"/>
+            <a:ext cx="10332720" cy="731520"/>
           </a:xfrm>
           <a:prstGeom prst="rect">
             <a:avLst/>
@@ -7436,29 +7620,29 @@
           </a:bodyPr>
           <a:lstStyle/>
           <a:p>
-            <a:pPr algn="l"/>
-            <a:r>
-              <a:rPr sz="1600" b="1" i="0">
-                <a:solidFill>
-                  <a:srgbClr val="C05014"/>
-                </a:solidFill>
-                <a:latin typeface="Arial"/>
-              </a:rPr>
-              <a:t>WRITE:</a:t>
-            </a:r>
-          </a:p>
-        </p:txBody>
-      </p:sp>
-      <p:sp>
-        <p:nvSpPr>
-          <p:cNvPr id="7" name="TextBox 6"/>
+            <a:pPr algn="ctr"/>
+            <a:r>
+              <a:rPr sz="2600" b="1">
+                <a:solidFill>
+                  <a:srgbClr val="1F3A5F"/>
+                </a:solidFill>
+                <a:latin typeface="Arial"/>
+              </a:rPr>
+              <a:t>Not moving → no change → no energy of motion.</a:t>
+            </a:r>
+          </a:p>
+        </p:txBody>
+      </p:sp>
+      <p:sp>
+        <p:nvSpPr>
+          <p:cNvPr id="6" name="TextBox 5"/>
           <p:cNvSpPr txBox="1"/>
           <p:nvPr/>
         </p:nvSpPr>
         <p:spPr>
           <a:xfrm>
-            <a:off x="1371600" y="2240280"/>
-            <a:ext cx="9418320" cy="640080"/>
+            <a:off x="11338560" y="6446520"/>
+            <a:ext cx="731520" cy="365760"/>
           </a:xfrm>
           <a:prstGeom prst="rect">
             <a:avLst/>
@@ -7471,198 +7655,15 @@
           </a:bodyPr>
           <a:lstStyle/>
           <a:p>
-            <a:pPr algn="l"/>
-            <a:r>
-              <a:rPr sz="2800" b="1" i="0">
-                <a:solidFill>
-                  <a:srgbClr val="1F3A5F"/>
-                </a:solidFill>
-                <a:latin typeface="Arial"/>
-              </a:rPr>
-              <a:t>An object is in motion when its position changes.</a:t>
-            </a:r>
-          </a:p>
-        </p:txBody>
-      </p:sp>
-      <p:sp>
-        <p:nvSpPr>
-          <p:cNvPr id="8" name="TextBox 7"/>
-          <p:cNvSpPr txBox="1"/>
-          <p:nvPr/>
-        </p:nvSpPr>
-        <p:spPr>
-          <a:xfrm>
-            <a:off x="1371600" y="3017520"/>
-            <a:ext cx="9418320" cy="457200"/>
-          </a:xfrm>
-          <a:prstGeom prst="rect">
-            <a:avLst/>
-          </a:prstGeom>
-          <a:noFill/>
-        </p:spPr>
-        <p:txBody>
-          <a:bodyPr wrap="square" anchor="t">
-            <a:spAutoFit/>
-          </a:bodyPr>
-          <a:lstStyle/>
-          <a:p>
-            <a:pPr algn="l"/>
-            <a:r>
-              <a:rPr sz="1600" b="0" i="1">
+            <a:pPr algn="r"/>
+            <a:r>
+              <a:rPr sz="1200" b="0">
                 <a:solidFill>
                   <a:srgbClr val="555555"/>
                 </a:solidFill>
                 <a:latin typeface="Arial"/>
               </a:rPr>
-              <a:t>REVEAL → POSITION</a:t>
-            </a:r>
-          </a:p>
-        </p:txBody>
-      </p:sp>
-      <p:sp>
-        <p:nvSpPr>
-          <p:cNvPr id="9" name="Rounded Rectangle 8"/>
-          <p:cNvSpPr/>
-          <p:nvPr/>
-        </p:nvSpPr>
-        <p:spPr>
-          <a:xfrm>
-            <a:off x="1097280" y="4206240"/>
-            <a:ext cx="9966960" cy="1828800"/>
-          </a:xfrm>
-          <a:prstGeom prst="roundRect">
-            <a:avLst/>
-          </a:prstGeom>
-          <a:solidFill>
-            <a:srgbClr val="2E6B3F"/>
-          </a:solidFill>
-          <a:ln>
-            <a:noFill/>
-          </a:ln>
-        </p:spPr>
-        <p:style>
-          <a:lnRef idx="1">
-            <a:schemeClr val="accent1"/>
-          </a:lnRef>
-          <a:fillRef idx="3">
-            <a:schemeClr val="accent1"/>
-          </a:fillRef>
-          <a:effectRef idx="2">
-            <a:schemeClr val="accent1"/>
-          </a:effectRef>
-          <a:fontRef idx="minor">
-            <a:schemeClr val="lt1"/>
-          </a:fontRef>
-        </p:style>
-        <p:txBody>
-          <a:bodyPr rtlCol="0" anchor="ctr" wrap="square"/>
-          <a:lstStyle/>
-          <a:p>
-            <a:pPr algn="ctr"/>
-          </a:p>
-        </p:txBody>
-      </p:sp>
-      <p:sp>
-        <p:nvSpPr>
-          <p:cNvPr id="10" name="TextBox 9"/>
-          <p:cNvSpPr txBox="1"/>
-          <p:nvPr/>
-        </p:nvSpPr>
-        <p:spPr>
-          <a:xfrm>
-            <a:off x="1371600" y="4297679"/>
-            <a:ext cx="9418320" cy="457200"/>
-          </a:xfrm>
-          <a:prstGeom prst="rect">
-            <a:avLst/>
-          </a:prstGeom>
-          <a:noFill/>
-        </p:spPr>
-        <p:txBody>
-          <a:bodyPr wrap="square" anchor="t">
-            <a:spAutoFit/>
-          </a:bodyPr>
-          <a:lstStyle/>
-          <a:p>
-            <a:pPr algn="l"/>
-            <a:r>
-              <a:rPr sz="1600" b="1" i="0">
-                <a:solidFill>
-                  <a:srgbClr val="FFFFFF"/>
-                </a:solidFill>
-                <a:latin typeface="Arial"/>
-              </a:rPr>
-              <a:t>DRAWING IDEAS (draw YOUR example):</a:t>
-            </a:r>
-          </a:p>
-        </p:txBody>
-      </p:sp>
-      <p:sp>
-        <p:nvSpPr>
-          <p:cNvPr id="11" name="TextBox 10"/>
-          <p:cNvSpPr txBox="1"/>
-          <p:nvPr/>
-        </p:nvSpPr>
-        <p:spPr>
-          <a:xfrm>
-            <a:off x="1463040" y="4754879"/>
-            <a:ext cx="9418320" cy="411480"/>
-          </a:xfrm>
-          <a:prstGeom prst="rect">
-            <a:avLst/>
-          </a:prstGeom>
-          <a:noFill/>
-        </p:spPr>
-        <p:txBody>
-          <a:bodyPr wrap="square" anchor="t">
-            <a:spAutoFit/>
-          </a:bodyPr>
-          <a:lstStyle/>
-          <a:p>
-            <a:pPr algn="l"/>
-            <a:r>
-              <a:rPr sz="1800" b="0" i="0">
-                <a:solidFill>
-                  <a:srgbClr val="FFFFFF"/>
-                </a:solidFill>
-                <a:latin typeface="Arial"/>
-              </a:rPr>
-              <a:t>•  draw a moving object</a:t>
-            </a:r>
-          </a:p>
-        </p:txBody>
-      </p:sp>
-      <p:sp>
-        <p:nvSpPr>
-          <p:cNvPr id="12" name="TextBox 11"/>
-          <p:cNvSpPr txBox="1"/>
-          <p:nvPr/>
-        </p:nvSpPr>
-        <p:spPr>
-          <a:xfrm>
-            <a:off x="1463040" y="5166359"/>
-            <a:ext cx="9418320" cy="411480"/>
-          </a:xfrm>
-          <a:prstGeom prst="rect">
-            <a:avLst/>
-          </a:prstGeom>
-          <a:noFill/>
-        </p:spPr>
-        <p:txBody>
-          <a:bodyPr wrap="square" anchor="t">
-            <a:spAutoFit/>
-          </a:bodyPr>
-          <a:lstStyle/>
-          <a:p>
-            <a:pPr algn="l"/>
-            <a:r>
-              <a:rPr sz="1800" b="0" i="0">
-                <a:solidFill>
-                  <a:srgbClr val="FFFFFF"/>
-                </a:solidFill>
-                <a:latin typeface="Arial"/>
-              </a:rPr>
-              <a:t>•  add an arrow to show direction</a:t>
+              <a:t>21</a:t>
             </a:r>
           </a:p>
         </p:txBody>
@@ -7737,7 +7738,7 @@
         <p:spPr>
           <a:xfrm>
             <a:off x="457200" y="146304"/>
-            <a:ext cx="10058400" cy="777240"/>
+            <a:ext cx="11247120" cy="777240"/>
           </a:xfrm>
           <a:prstGeom prst="rect">
             <a:avLst/>
@@ -7752,13 +7753,13 @@
           <a:p>
             <a:pPr algn="l"/>
             <a:r>
-              <a:rPr sz="3400" b="1" i="0">
+              <a:rPr sz="3400" b="1">
                 <a:solidFill>
                   <a:srgbClr val="FFFFFF"/>
                 </a:solidFill>
                 <a:latin typeface="Arial"/>
               </a:rPr>
-              <a:t>Notebook — Energy of Motion</a:t>
+              <a:t>Bring it together</a:t>
             </a:r>
           </a:p>
         </p:txBody>
@@ -7771,8 +7772,8 @@
         </p:nvSpPr>
         <p:spPr>
           <a:xfrm>
-            <a:off x="9692640" y="256032"/>
-            <a:ext cx="2103120" cy="548640"/>
+            <a:off x="822960" y="2286000"/>
+            <a:ext cx="2926080" cy="1371600"/>
           </a:xfrm>
           <a:prstGeom prst="roundRect">
             <a:avLst/>
@@ -7804,27 +7805,70 @@
           <a:p>
             <a:pPr algn="ctr"/>
             <a:r>
-              <a:rPr sz="1800" b="1">
+              <a:rPr sz="2200" b="1">
                 <a:solidFill>
                   <a:srgbClr val="FFFFFF"/>
                 </a:solidFill>
                 <a:latin typeface="Arial"/>
               </a:rPr>
-              <a:t>NOTEBOOK</a:t>
-            </a:r>
-          </a:p>
-        </p:txBody>
-      </p:sp>
-      <p:sp>
-        <p:nvSpPr>
-          <p:cNvPr id="5" name="Rounded Rectangle 4"/>
+              <a:t>MOVING OBJECT</a:t>
+            </a:r>
+          </a:p>
+        </p:txBody>
+      </p:sp>
+      <p:sp>
+        <p:nvSpPr>
+          <p:cNvPr id="5" name="Right Arrow 4"/>
           <p:cNvSpPr/>
           <p:nvPr/>
         </p:nvSpPr>
         <p:spPr>
           <a:xfrm>
-            <a:off x="1097280" y="1737360"/>
-            <a:ext cx="9966960" cy="1234440"/>
+            <a:off x="3840480" y="2834640"/>
+            <a:ext cx="822960" cy="548640"/>
+          </a:xfrm>
+          <a:prstGeom prst="rightArrow">
+            <a:avLst/>
+          </a:prstGeom>
+          <a:solidFill>
+            <a:srgbClr val="C05014"/>
+          </a:solidFill>
+          <a:ln>
+            <a:noFill/>
+          </a:ln>
+        </p:spPr>
+        <p:style>
+          <a:lnRef idx="1">
+            <a:schemeClr val="accent1"/>
+          </a:lnRef>
+          <a:fillRef idx="3">
+            <a:schemeClr val="accent1"/>
+          </a:fillRef>
+          <a:effectRef idx="2">
+            <a:schemeClr val="accent1"/>
+          </a:effectRef>
+          <a:fontRef idx="minor">
+            <a:schemeClr val="lt1"/>
+          </a:fontRef>
+        </p:style>
+        <p:txBody>
+          <a:bodyPr rtlCol="0" anchor="ctr"/>
+          <a:lstStyle/>
+          <a:p>
+            <a:pPr algn="ctr"/>
+          </a:p>
+        </p:txBody>
+      </p:sp>
+      <p:sp>
+        <p:nvSpPr>
+          <p:cNvPr id="6" name="Rounded Rectangle 5"/>
+          <p:cNvSpPr/>
+          <p:nvPr/>
+        </p:nvSpPr>
+        <p:spPr>
+          <a:xfrm>
+            <a:off x="4754880" y="2286000"/>
+            <a:ext cx="2743200" cy="1371600"/>
           </a:xfrm>
           <a:prstGeom prst="roundRect">
             <a:avLst/>
@@ -7855,124 +7899,71 @@
           <a:lstStyle/>
           <a:p>
             <a:pPr algn="ctr"/>
-          </a:p>
-        </p:txBody>
-      </p:sp>
-      <p:sp>
-        <p:nvSpPr>
-          <p:cNvPr id="6" name="TextBox 5"/>
-          <p:cNvSpPr txBox="1"/>
-          <p:nvPr/>
-        </p:nvSpPr>
-        <p:spPr>
-          <a:xfrm>
-            <a:off x="1371600" y="1828800"/>
-            <a:ext cx="9418320" cy="457200"/>
-          </a:xfrm>
-          <a:prstGeom prst="rect">
-            <a:avLst/>
-          </a:prstGeom>
-          <a:noFill/>
-        </p:spPr>
-        <p:txBody>
-          <a:bodyPr wrap="square" anchor="t">
-            <a:spAutoFit/>
-          </a:bodyPr>
-          <a:lstStyle/>
-          <a:p>
-            <a:pPr algn="l"/>
-            <a:r>
-              <a:rPr sz="1600" b="1" i="0">
-                <a:solidFill>
-                  <a:srgbClr val="C05014"/>
-                </a:solidFill>
-                <a:latin typeface="Arial"/>
-              </a:rPr>
-              <a:t>WRITE:</a:t>
-            </a:r>
-          </a:p>
-        </p:txBody>
-      </p:sp>
-      <p:sp>
-        <p:nvSpPr>
-          <p:cNvPr id="7" name="TextBox 6"/>
-          <p:cNvSpPr txBox="1"/>
-          <p:nvPr/>
-        </p:nvSpPr>
-        <p:spPr>
-          <a:xfrm>
-            <a:off x="1371600" y="2240280"/>
-            <a:ext cx="9418320" cy="640080"/>
-          </a:xfrm>
-          <a:prstGeom prst="rect">
-            <a:avLst/>
-          </a:prstGeom>
-          <a:noFill/>
-        </p:spPr>
-        <p:txBody>
-          <a:bodyPr wrap="square" anchor="t">
-            <a:spAutoFit/>
-          </a:bodyPr>
-          <a:lstStyle/>
-          <a:p>
-            <a:pPr algn="l"/>
-            <a:r>
-              <a:rPr sz="2800" b="1" i="0">
+            <a:r>
+              <a:rPr sz="2600" b="1">
                 <a:solidFill>
                   <a:srgbClr val="1F3A5F"/>
                 </a:solidFill>
                 <a:latin typeface="Arial"/>
               </a:rPr>
-              <a:t>A moving object has energy of motion.</a:t>
-            </a:r>
-          </a:p>
-        </p:txBody>
-      </p:sp>
-      <p:sp>
-        <p:nvSpPr>
-          <p:cNvPr id="8" name="TextBox 7"/>
-          <p:cNvSpPr txBox="1"/>
-          <p:nvPr/>
-        </p:nvSpPr>
-        <p:spPr>
-          <a:xfrm>
-            <a:off x="1371600" y="3017520"/>
-            <a:ext cx="9418320" cy="457200"/>
-          </a:xfrm>
-          <a:prstGeom prst="rect">
-            <a:avLst/>
-          </a:prstGeom>
-          <a:noFill/>
-        </p:spPr>
-        <p:txBody>
-          <a:bodyPr wrap="square" anchor="t">
-            <a:spAutoFit/>
-          </a:bodyPr>
-          <a:lstStyle/>
-          <a:p>
-            <a:pPr algn="l"/>
-            <a:r>
-              <a:rPr sz="1600" b="0" i="1">
-                <a:solidFill>
-                  <a:srgbClr val="555555"/>
-                </a:solidFill>
-                <a:latin typeface="Arial"/>
-              </a:rPr>
-              <a:t>REVEAL → MOTION</a:t>
-            </a:r>
-          </a:p>
-        </p:txBody>
-      </p:sp>
-      <p:sp>
-        <p:nvSpPr>
-          <p:cNvPr id="9" name="Rounded Rectangle 8"/>
+              <a:t>CHANGE</a:t>
+            </a:r>
+          </a:p>
+        </p:txBody>
+      </p:sp>
+      <p:sp>
+        <p:nvSpPr>
+          <p:cNvPr id="7" name="Right Arrow 6"/>
           <p:cNvSpPr/>
           <p:nvPr/>
         </p:nvSpPr>
         <p:spPr>
           <a:xfrm>
-            <a:off x="1097280" y="4206240"/>
-            <a:ext cx="9966960" cy="1828800"/>
+            <a:off x="7589520" y="2834640"/>
+            <a:ext cx="822960" cy="548640"/>
+          </a:xfrm>
+          <a:prstGeom prst="rightArrow">
+            <a:avLst/>
+          </a:prstGeom>
+          <a:solidFill>
+            <a:srgbClr val="C05014"/>
+          </a:solidFill>
+          <a:ln>
+            <a:noFill/>
+          </a:ln>
+        </p:spPr>
+        <p:style>
+          <a:lnRef idx="1">
+            <a:schemeClr val="accent1"/>
+          </a:lnRef>
+          <a:fillRef idx="3">
+            <a:schemeClr val="accent1"/>
+          </a:fillRef>
+          <a:effectRef idx="2">
+            <a:schemeClr val="accent1"/>
+          </a:effectRef>
+          <a:fontRef idx="minor">
+            <a:schemeClr val="lt1"/>
+          </a:fontRef>
+        </p:style>
+        <p:txBody>
+          <a:bodyPr rtlCol="0" anchor="ctr"/>
+          <a:lstStyle/>
+          <a:p>
+            <a:pPr algn="ctr"/>
+          </a:p>
+        </p:txBody>
+      </p:sp>
+      <p:sp>
+        <p:nvSpPr>
+          <p:cNvPr id="8" name="Rounded Rectangle 7"/>
+          <p:cNvSpPr/>
+          <p:nvPr/>
+        </p:nvSpPr>
+        <p:spPr>
+          <a:xfrm>
+            <a:off x="8503920" y="2286000"/>
+            <a:ext cx="2743200" cy="1371600"/>
           </a:xfrm>
           <a:prstGeom prst="roundRect">
             <a:avLst/>
@@ -8003,19 +7994,28 @@
           <a:lstStyle/>
           <a:p>
             <a:pPr algn="ctr"/>
-          </a:p>
-        </p:txBody>
-      </p:sp>
-      <p:sp>
-        <p:nvSpPr>
-          <p:cNvPr id="10" name="TextBox 9"/>
+            <a:r>
+              <a:rPr sz="2400" b="1">
+                <a:solidFill>
+                  <a:srgbClr val="FFFFFF"/>
+                </a:solidFill>
+                <a:latin typeface="Arial"/>
+              </a:rPr>
+              <a:t>EVIDENCE</a:t>
+            </a:r>
+          </a:p>
+        </p:txBody>
+      </p:sp>
+      <p:sp>
+        <p:nvSpPr>
+          <p:cNvPr id="9" name="TextBox 8"/>
           <p:cNvSpPr txBox="1"/>
           <p:nvPr/>
         </p:nvSpPr>
         <p:spPr>
           <a:xfrm>
-            <a:off x="1371600" y="4297679"/>
-            <a:ext cx="9418320" cy="457200"/>
+            <a:off x="822960" y="4480560"/>
+            <a:ext cx="10515600" cy="822960"/>
           </a:xfrm>
           <a:prstGeom prst="rect">
             <a:avLst/>
@@ -8028,29 +8028,29 @@
           </a:bodyPr>
           <a:lstStyle/>
           <a:p>
-            <a:pPr algn="l"/>
-            <a:r>
-              <a:rPr sz="1600" b="1" i="0">
-                <a:solidFill>
-                  <a:srgbClr val="FFFFFF"/>
-                </a:solidFill>
-                <a:latin typeface="Arial"/>
-              </a:rPr>
-              <a:t>DRAWING IDEAS (draw YOUR example):</a:t>
-            </a:r>
-          </a:p>
-        </p:txBody>
-      </p:sp>
-      <p:sp>
-        <p:nvSpPr>
-          <p:cNvPr id="11" name="TextBox 10"/>
+            <a:pPr algn="ctr"/>
+            <a:r>
+              <a:rPr sz="2400" b="1">
+                <a:solidFill>
+                  <a:srgbClr val="1F3A5F"/>
+                </a:solidFill>
+                <a:latin typeface="Arial"/>
+              </a:rPr>
+              <a:t>Name one moving object and the change it caused.</a:t>
+            </a:r>
+          </a:p>
+        </p:txBody>
+      </p:sp>
+      <p:sp>
+        <p:nvSpPr>
+          <p:cNvPr id="10" name="TextBox 9"/>
           <p:cNvSpPr txBox="1"/>
           <p:nvPr/>
         </p:nvSpPr>
         <p:spPr>
           <a:xfrm>
-            <a:off x="1463040" y="4754879"/>
-            <a:ext cx="9418320" cy="411480"/>
+            <a:off x="11338560" y="6446520"/>
+            <a:ext cx="731520" cy="365760"/>
           </a:xfrm>
           <a:prstGeom prst="rect">
             <a:avLst/>
@@ -8063,15 +8063,15 @@
           </a:bodyPr>
           <a:lstStyle/>
           <a:p>
-            <a:pPr algn="l"/>
-            <a:r>
-              <a:rPr sz="1800" b="0" i="0">
-                <a:solidFill>
-                  <a:srgbClr val="FFFFFF"/>
-                </a:solidFill>
-                <a:latin typeface="Arial"/>
-              </a:rPr>
-              <a:t>•  draw a moving object causing something else to change</a:t>
+            <a:pPr algn="r"/>
+            <a:r>
+              <a:rPr sz="1200" b="0">
+                <a:solidFill>
+                  <a:srgbClr val="555555"/>
+                </a:solidFill>
+                <a:latin typeface="Arial"/>
+              </a:rPr>
+              <a:t>22</a:t>
             </a:r>
           </a:p>
         </p:txBody>

</xml_diff>